<commit_message>
feat(mahalla): region→district→mahalla cascade + backend delta sync
- Territory: GET /region + /district endpoints, RegionDto/DistrictDto types,
  useRegionsQuery/useDistrictsQuery hooks, mahalla.service getRegions/getDistricts
- join.tsx: 3-step Region → District → Mahalla onboarding wizard (breadcrumb),
  filters mahallas by district_id; household step unchanged
- MahallaDto/MahallaListParams: add district_id, region_id
- Gas: gate receipt-confirm on verified membership (§10); relabel the
  "order broken" warning (§7); cancel/distributor-role already in place
- service detail: resolve relative image URLs via resolveImageUrl (fix blank images)
- i18n: mahalla + gas keys (uz/ru/en)

Co-Authored-By: Claude Opus 4.8 <noreply@anthropic.com>
</commit_message>
<xml_diff>
--- a/docs/Hana_Market_PTA_Pitch.pptx
+++ b/docs/Hana_Market_PTA_Pitch.pptx
@@ -4,6 +4,9 @@
   <p:sldMasterIdLst>
     <p:sldMasterId id="2147483648" r:id="rId1"/>
   </p:sldMasterIdLst>
+  <p:notesMasterIdLst>
+    <p:notesMasterId r:id="rId14"/>
+  </p:notesMasterIdLst>
   <p:sldIdLst>
     <p:sldId id="256" r:id="rId2"/>
     <p:sldId id="257" r:id="rId3"/>
@@ -18,11 +21,8 @@
     <p:sldId id="266" r:id="rId12"/>
     <p:sldId id="267" r:id="rId13"/>
   </p:sldIdLst>
-  <p:notesMasterIdLst>
-    <p:notesMasterId r:id="rId14"/>
-  </p:notesMasterIdLst>
-  <p:sldSz cx="12191695" cy="6858000"/>
-  <p:notesSz cx="6858000" cy="12191695"/>
+  <p:sldSz cx="12192000" cy="6858000"/>
+  <p:notesSz cx="6858000" cy="12192000"/>
   <p:defaultTextStyle>
     <a:lvl1pPr marL="0" algn="l" defTabSz="914400" rtl="0" eaLnBrk="1" latinLnBrk="0" hangingPunct="1">
       <a:defRPr sz="1800" kern="1200">
@@ -115,6 +115,11 @@
       </a:defRPr>
     </a:lvl9pPr>
   </p:defaultTextStyle>
+  <p:extLst>
+    <p:ext uri="{EFAFB233-063F-42B5-8137-9DF3F51BA10A}">
+      <p15:sldGuideLst xmlns:p15="http://schemas.microsoft.com/office/powerpoint/2012/main"/>
+    </p:ext>
+  </p:extLst>
 </p:presentation>
 </file>
 
@@ -140,240 +145,16 @@
           <a:chExt cx="0" cy="0"/>
         </a:xfrm>
       </p:grpSpPr>
-      <p:sp>
-        <p:nvSpPr>
-          <p:cNvPr id="2" name="Header Placeholder 1"/>
-          <p:cNvSpPr>
-            <a:spLocks noGrp="1"/>
-          </p:cNvSpPr>
-          <p:nvPr>
-            <p:ph type="hdr" sz="quarter"/>
-          </p:nvPr>
-        </p:nvSpPr>
-        <p:spPr>
-          <a:xfrm>
-            <a:off x="0" y="0"/>
-            <a:ext cx="2971800" cy="458788"/>
-          </a:xfrm>
-          <a:prstGeom prst="rect">
-            <a:avLst/>
-          </a:prstGeom>
-        </p:spPr>
-        <p:txBody>
-          <a:bodyPr vert="horz" lIns="91440" tIns="45720" rIns="91440" bIns="45720" rtlCol="0"/>
-          <a:lstStyle>
-            <a:lvl1pPr algn="l">
-              <a:defRPr sz="1200"/>
-            </a:lvl1pPr>
-          </a:lstStyle>
-          <a:p>
-            <a:endParaRPr lang="en-US"/>
-          </a:p>
-        </p:txBody>
-      </p:sp>
-      <p:sp>
-        <p:nvSpPr>
-          <p:cNvPr id="3" name="Date Placeholder 2"/>
-          <p:cNvSpPr>
-            <a:spLocks noGrp="1"/>
-          </p:cNvSpPr>
-          <p:nvPr>
-            <p:ph type="dt" idx="1"/>
-          </p:nvPr>
-        </p:nvSpPr>
-        <p:spPr>
-          <a:xfrm>
-            <a:off x="3884613" y="0"/>
-            <a:ext cx="2971800" cy="458788"/>
-          </a:xfrm>
-          <a:prstGeom prst="rect">
-            <a:avLst/>
-          </a:prstGeom>
-        </p:spPr>
-        <p:txBody>
-          <a:bodyPr vert="horz" lIns="91440" tIns="45720" rIns="91440" bIns="45720" rtlCol="0"/>
-          <a:lstStyle>
-            <a:lvl1pPr algn="r">
-              <a:defRPr sz="1200"/>
-            </a:lvl1pPr>
-          </a:lstStyle>
-          <a:p>
-            <a:fld id="{5282F153-3F37-0F45-9E97-73ACFA13230C}" type="datetimeFigureOut">
-              <a:rPr lang="en-US"/>
-              <a:t>7/23/19</a:t>
-            </a:fld>
-            <a:endParaRPr lang="en-US"/>
-          </a:p>
-        </p:txBody>
-      </p:sp>
-      <p:sp>
-        <p:nvSpPr>
-          <p:cNvPr id="4" name="Slide Image Placeholder 3"/>
-          <p:cNvSpPr>
-            <a:spLocks noGrp="1" noRot="1" noChangeAspect="1"/>
-          </p:cNvSpPr>
-          <p:nvPr>
-            <p:ph type="sldImg" idx="2"/>
-          </p:nvPr>
-        </p:nvSpPr>
-        <p:spPr>
-          <a:xfrm>
-            <a:off x="685800" y="1143000"/>
-            <a:ext cx="5486400" cy="3086100"/>
-          </a:xfrm>
-          <a:prstGeom prst="rect">
-            <a:avLst/>
-          </a:prstGeom>
-          <a:noFill/>
-          <a:ln w="12700">
-            <a:solidFill>
-              <a:prstClr val="black"/>
-            </a:solidFill>
-          </a:ln>
-        </p:spPr>
-        <p:txBody>
-          <a:bodyPr vert="horz" lIns="91440" tIns="45720" rIns="91440" bIns="45720" rtlCol="0" anchor="ctr"/>
-          <a:lstStyle/>
-          <a:p>
-            <a:endParaRPr lang="en-US"/>
-          </a:p>
-        </p:txBody>
-      </p:sp>
-      <p:sp>
-        <p:nvSpPr>
-          <p:cNvPr id="5" name="Notes Placeholder 4"/>
-          <p:cNvSpPr>
-            <a:spLocks noGrp="1"/>
-          </p:cNvSpPr>
-          <p:nvPr>
-            <p:ph type="body" sz="quarter" idx="3"/>
-          </p:nvPr>
-        </p:nvSpPr>
-        <p:spPr>
-          <a:xfrm>
-            <a:off x="685800" y="4400550"/>
-            <a:ext cx="5486400" cy="3600450"/>
-          </a:xfrm>
-          <a:prstGeom prst="rect">
-            <a:avLst/>
-          </a:prstGeom>
-        </p:spPr>
-        <p:txBody>
-          <a:bodyPr vert="horz" lIns="91440" tIns="45720" rIns="91440" bIns="45720" rtlCol="0"/>
-          <a:lstStyle/>
-          <a:p>
-            <a:pPr lvl="0"/>
-            <a:r>
-              <a:rPr lang="en-US"/>
-              <a:t>Click to edit Master text styles</a:t>
-            </a:r>
-          </a:p>
-          <a:p>
-            <a:pPr lvl="1"/>
-            <a:r>
-              <a:rPr lang="en-US"/>
-              <a:t>Second level</a:t>
-            </a:r>
-          </a:p>
-          <a:p>
-            <a:pPr lvl="2"/>
-            <a:r>
-              <a:rPr lang="en-US"/>
-              <a:t>Third level</a:t>
-            </a:r>
-          </a:p>
-          <a:p>
-            <a:pPr lvl="3"/>
-            <a:r>
-              <a:rPr lang="en-US"/>
-              <a:t>Fourth level</a:t>
-            </a:r>
-          </a:p>
-          <a:p>
-            <a:pPr lvl="4"/>
-            <a:r>
-              <a:rPr lang="en-US"/>
-              <a:t>Fifth level</a:t>
-            </a:r>
-          </a:p>
-        </p:txBody>
-      </p:sp>
-      <p:sp>
-        <p:nvSpPr>
-          <p:cNvPr id="6" name="Footer Placeholder 5"/>
-          <p:cNvSpPr>
-            <a:spLocks noGrp="1"/>
-          </p:cNvSpPr>
-          <p:nvPr>
-            <p:ph type="ftr" sz="quarter" idx="4"/>
-          </p:nvPr>
-        </p:nvSpPr>
-        <p:spPr>
-          <a:xfrm>
-            <a:off x="0" y="8685213"/>
-            <a:ext cx="2971800" cy="458787"/>
-          </a:xfrm>
-          <a:prstGeom prst="rect">
-            <a:avLst/>
-          </a:prstGeom>
-        </p:spPr>
-        <p:txBody>
-          <a:bodyPr vert="horz" lIns="91440" tIns="45720" rIns="91440" bIns="45720" rtlCol="0" anchor="b"/>
-          <a:lstStyle>
-            <a:lvl1pPr algn="l">
-              <a:defRPr sz="1200"/>
-            </a:lvl1pPr>
-          </a:lstStyle>
-          <a:p>
-            <a:endParaRPr lang="en-US"/>
-          </a:p>
-        </p:txBody>
-      </p:sp>
-      <p:sp>
-        <p:nvSpPr>
-          <p:cNvPr id="7" name="Slide Number Placeholder 6"/>
-          <p:cNvSpPr>
-            <a:spLocks noGrp="1"/>
-          </p:cNvSpPr>
-          <p:nvPr>
-            <p:ph type="sldNum" sz="quarter" idx="5"/>
-          </p:nvPr>
-        </p:nvSpPr>
-        <p:spPr>
-          <a:xfrm>
-            <a:off x="3884613" y="8685213"/>
-            <a:ext cx="2971800" cy="458787"/>
-          </a:xfrm>
-          <a:prstGeom prst="rect">
-            <a:avLst/>
-          </a:prstGeom>
-        </p:spPr>
-        <p:txBody>
-          <a:bodyPr vert="horz" lIns="91440" tIns="45720" rIns="91440" bIns="45720" rtlCol="0" anchor="b"/>
-          <a:lstStyle>
-            <a:lvl1pPr algn="r">
-              <a:defRPr sz="1200"/>
-            </a:lvl1pPr>
-          </a:lstStyle>
-          <a:p>
-            <a:fld id="{CE5E9CC1-C706-0F49-92D6-E571CC5EEA8F}" type="slidenum">
-              <a:rPr lang="en-US"/>
-              <a:t>‹#›</a:t>
-            </a:fld>
-            <a:endParaRPr lang="en-US"/>
-          </a:p>
-        </p:txBody>
-      </p:sp>
     </p:spTree>
     <p:extLst>
       <p:ext uri="{BB962C8B-B14F-4D97-AF65-F5344CB8AC3E}">
-        <p14:creationId xmlns:p14="http://schemas.microsoft.com/office/powerpoint/2010/main" val="1024086991"/>
+        <p14:creationId xmlns:p14="http://schemas.microsoft.com/office/powerpoint/2010/main" val="2249062358"/>
       </p:ext>
     </p:extLst>
   </p:cSld>
   <p:clrMap bg1="lt1" tx1="dk1" bg2="lt2" tx2="dk2" accent1="accent1" accent2="accent2" accent3="accent3" accent4="accent4" accent5="accent5" accent6="accent6" hlink="hlink" folHlink="folHlink"/>
   <p:notesStyle>
-    <a:lvl1pPr marL="0" algn="l" defTabSz="914400" rtl="0" eaLnBrk="1" latinLnBrk="0" hangingPunct="1">
+    <a:lvl1pPr marL="0" algn="l" defTabSz="914400" rtl="0" eaLnBrk="1" latinLnBrk="1" hangingPunct="1">
       <a:defRPr sz="1200" kern="1200">
         <a:solidFill>
           <a:schemeClr val="tx1"/>
@@ -383,7 +164,7 @@
         <a:cs typeface="+mn-cs"/>
       </a:defRPr>
     </a:lvl1pPr>
-    <a:lvl2pPr marL="457200" algn="l" defTabSz="914400" rtl="0" eaLnBrk="1" latinLnBrk="0" hangingPunct="1">
+    <a:lvl2pPr marL="457200" algn="l" defTabSz="914400" rtl="0" eaLnBrk="1" latinLnBrk="1" hangingPunct="1">
       <a:defRPr sz="1200" kern="1200">
         <a:solidFill>
           <a:schemeClr val="tx1"/>
@@ -393,7 +174,7 @@
         <a:cs typeface="+mn-cs"/>
       </a:defRPr>
     </a:lvl2pPr>
-    <a:lvl3pPr marL="914400" algn="l" defTabSz="914400" rtl="0" eaLnBrk="1" latinLnBrk="0" hangingPunct="1">
+    <a:lvl3pPr marL="914400" algn="l" defTabSz="914400" rtl="0" eaLnBrk="1" latinLnBrk="1" hangingPunct="1">
       <a:defRPr sz="1200" kern="1200">
         <a:solidFill>
           <a:schemeClr val="tx1"/>
@@ -403,7 +184,7 @@
         <a:cs typeface="+mn-cs"/>
       </a:defRPr>
     </a:lvl3pPr>
-    <a:lvl4pPr marL="1371600" algn="l" defTabSz="914400" rtl="0" eaLnBrk="1" latinLnBrk="0" hangingPunct="1">
+    <a:lvl4pPr marL="1371600" algn="l" defTabSz="914400" rtl="0" eaLnBrk="1" latinLnBrk="1" hangingPunct="1">
       <a:defRPr sz="1200" kern="1200">
         <a:solidFill>
           <a:schemeClr val="tx1"/>
@@ -413,7 +194,7 @@
         <a:cs typeface="+mn-cs"/>
       </a:defRPr>
     </a:lvl4pPr>
-    <a:lvl5pPr marL="1828800" algn="l" defTabSz="914400" rtl="0" eaLnBrk="1" latinLnBrk="0" hangingPunct="1">
+    <a:lvl5pPr marL="1828800" algn="l" defTabSz="914400" rtl="0" eaLnBrk="1" latinLnBrk="1" hangingPunct="1">
       <a:defRPr sz="1200" kern="1200">
         <a:solidFill>
           <a:schemeClr val="tx1"/>
@@ -423,7 +204,7 @@
         <a:cs typeface="+mn-cs"/>
       </a:defRPr>
     </a:lvl5pPr>
-    <a:lvl6pPr marL="2286000" algn="l" defTabSz="914400" rtl="0" eaLnBrk="1" latinLnBrk="0" hangingPunct="1">
+    <a:lvl6pPr marL="2286000" algn="l" defTabSz="914400" rtl="0" eaLnBrk="1" latinLnBrk="1" hangingPunct="1">
       <a:defRPr sz="1200" kern="1200">
         <a:solidFill>
           <a:schemeClr val="tx1"/>
@@ -433,7 +214,7 @@
         <a:cs typeface="+mn-cs"/>
       </a:defRPr>
     </a:lvl6pPr>
-    <a:lvl7pPr marL="2743200" algn="l" defTabSz="914400" rtl="0" eaLnBrk="1" latinLnBrk="0" hangingPunct="1">
+    <a:lvl7pPr marL="2743200" algn="l" defTabSz="914400" rtl="0" eaLnBrk="1" latinLnBrk="1" hangingPunct="1">
       <a:defRPr sz="1200" kern="1200">
         <a:solidFill>
           <a:schemeClr val="tx1"/>
@@ -443,7 +224,7 @@
         <a:cs typeface="+mn-cs"/>
       </a:defRPr>
     </a:lvl7pPr>
-    <a:lvl8pPr marL="3200400" algn="l" defTabSz="914400" rtl="0" eaLnBrk="1" latinLnBrk="0" hangingPunct="1">
+    <a:lvl8pPr marL="3200400" algn="l" defTabSz="914400" rtl="0" eaLnBrk="1" latinLnBrk="1" hangingPunct="1">
       <a:defRPr sz="1200" kern="1200">
         <a:solidFill>
           <a:schemeClr val="tx1"/>
@@ -453,7 +234,7 @@
         <a:cs typeface="+mn-cs"/>
       </a:defRPr>
     </a:lvl8pPr>
-    <a:lvl9pPr marL="3657600" algn="l" defTabSz="914400" rtl="0" eaLnBrk="1" latinLnBrk="0" hangingPunct="1">
+    <a:lvl9pPr marL="3657600" algn="l" defTabSz="914400" rtl="0" eaLnBrk="1" latinLnBrk="1" hangingPunct="1">
       <a:defRPr sz="1200" kern="1200">
         <a:solidFill>
           <a:schemeClr val="tx1"/>
@@ -515,7 +296,6 @@
               <a:rPr lang="en-US" dirty="0"/>
               <a:t>Biz Hana Market ustida ishlaymiz — mahalla hayotini raqamlashtiruvchi ilova. Bugun real muammoni va biz allaqachon qurib, ishga tushirgan yechimni ko'rsataman.</a:t>
             </a:r>
-            <a:endParaRPr lang="en-US" dirty="0"/>
           </a:p>
         </p:txBody>
       </p:sp>
@@ -603,7 +383,6 @@
               <a:rPr lang="en-US" dirty="0"/>
               <a:t>Biz g'oya emas, ijro qila oladigan jamoamiz — buni Play Store'da jonli mahsulot va pilot isbotlaydi.</a:t>
             </a:r>
-            <a:endParaRPr lang="en-US" dirty="0"/>
           </a:p>
         </p:txBody>
       </p:sp>
@@ -691,7 +470,6 @@
               <a:rPr lang="en-US" dirty="0"/>
               <a:t>Bizga texnik yordam kerak emas — bizga bozorga chiqish, zichlik va grant kerak. Aynan shuni dastur beradi.</a:t>
             </a:r>
-            <a:endParaRPr lang="en-US" dirty="0"/>
           </a:p>
         </p:txBody>
       </p:sp>
@@ -779,7 +557,6 @@
               <a:rPr lang="en-US" dirty="0"/>
               <a:t>Biz O'zbekistonning har bir mahallasi uchun raqamli operatsion tizim quramiz. Gaz navbati — shunchaki boshlanishi.</a:t>
             </a:r>
-            <a:endParaRPr lang="en-US" dirty="0"/>
           </a:p>
         </p:txBody>
       </p:sp>
@@ -867,7 +644,6 @@
               <a:rPr lang="en-US" dirty="0"/>
               <a:t>Bularning hammasini bugun odamlar og'zaki yoki tartibsiz Telegram guruhlari orqali hal qiladi. Natija — behuda vaqt, adolatsizlik, ishonchsizlik.</a:t>
             </a:r>
-            <a:endParaRPr lang="en-US" dirty="0"/>
           </a:p>
         </p:txBody>
       </p:sp>
@@ -955,7 +731,6 @@
               <a:rPr lang="en-US" dirty="0"/>
               <a:t>Marketplace odam oyiga bir-ikki marta ochadi. Gaz yoki mahalla ma'lumoti — har kuni. Biz yuqori chastotali qatlam ustiga savdoni qo'yamiz.</a:t>
             </a:r>
-            <a:endParaRPr lang="en-US" dirty="0"/>
           </a:p>
         </p:txBody>
       </p:sp>
@@ -1043,7 +818,6 @@
               <a:rPr lang="en-US" dirty="0"/>
               <a:t>Vaqt to'g'ri: texnologiya tayyor, madaniy asos bor, davlat yo'nalishi bir xil.</a:t>
             </a:r>
-            <a:endParaRPr lang="en-US" dirty="0"/>
           </a:p>
         </p:txBody>
       </p:sp>
@@ -1131,7 +905,6 @@
               <a:rPr lang="en-US" dirty="0"/>
               <a:t>Ko'p ishtirokchi slayd bilan keladi. Bizda — Play Store'da nashr etilgan, real ishlaydigan ilova. Texnik risklarni allaqachon hal qildik.</a:t>
             </a:r>
-            <a:endParaRPr lang="en-US" dirty="0"/>
           </a:p>
         </p:txBody>
       </p:sp>
@@ -1219,7 +992,6 @@
               <a:rPr lang="en-US" dirty="0"/>
               <a:t>Bu — bizning noyob wedge. Davlat "yetkazib ber" dedi; biz "shaffof va adolatli qil" deymiz. Hech bir raqobatchida bu yo'q.</a:t>
             </a:r>
-            <a:endParaRPr lang="en-US" dirty="0"/>
           </a:p>
         </p:txBody>
       </p:sp>
@@ -1307,7 +1079,6 @@
               <a:rPr lang="en-US" dirty="0"/>
               <a:t>Gaz taqsimoti odatda adolatsiz — tarqatuvchi oson uylardan boshlaydi. Biz buni algoritm bilan hal qilamiz: davom, prioritet, va ochiq nazorat.</a:t>
             </a:r>
-            <a:endParaRPr lang="en-US" dirty="0"/>
           </a:p>
         </p:txBody>
       </p:sp>
@@ -1395,7 +1166,6 @@
               <a:rPr lang="en-US" dirty="0"/>
               <a:t>Raqobatchilar savdo maydonida. Biz — mahalla infratuzilmasi maydonida, u yerda hech kim yo'q. Bu himoyalanadigan nisha.</a:t>
             </a:r>
-            <a:endParaRPr lang="en-US" dirty="0"/>
           </a:p>
         </p:txBody>
       </p:sp>
@@ -1483,7 +1253,6 @@
               <a:rPr lang="en-US" dirty="0"/>
               <a:t>Avval yuqori chastotali auditoriya to'playmiz, keyin mahalliy bizneslar shu auditoriyaga chiqish uchun to'laydi.</a:t>
             </a:r>
-            <a:endParaRPr lang="en-US" dirty="0"/>
           </a:p>
         </p:txBody>
       </p:sp>
@@ -1556,6 +1325,11 @@
 <file path=ppt/slideMasters/slideMaster1.xml><?xml version="1.0" encoding="utf-8"?>
 <p:sldMaster xmlns:a="http://schemas.openxmlformats.org/drawingml/2006/main" xmlns:r="http://schemas.openxmlformats.org/officeDocument/2006/relationships" xmlns:p="http://schemas.openxmlformats.org/presentationml/2006/main">
   <p:cSld>
+    <p:bg>
+      <p:bgRef idx="1001">
+        <a:schemeClr val="bg1"/>
+      </p:bgRef>
+    </p:bg>
     <p:spTree>
       <p:nvGrpSpPr>
         <p:cNvPr id="1" name=""/>
@@ -1838,6 +1612,7 @@
         <a:solidFill>
           <a:srgbClr val="0F1E16"/>
         </a:solidFill>
+        <a:effectLst/>
       </p:bgPr>
     </p:bg>
     <p:spTree>
@@ -1873,6 +1648,13 @@
           </a:solidFill>
           <a:ln/>
         </p:spPr>
+        <p:txBody>
+          <a:bodyPr/>
+          <a:lstStyle/>
+          <a:p>
+            <a:endParaRPr lang="ko-KR" altLang="en-US"/>
+          </a:p>
+        </p:txBody>
       </p:sp>
       <p:sp>
         <p:nvSpPr>
@@ -1893,6 +1675,13 @@
           </a:solidFill>
           <a:ln/>
         </p:spPr>
+        <p:txBody>
+          <a:bodyPr/>
+          <a:lstStyle/>
+          <a:p>
+            <a:endParaRPr lang="ko-KR" altLang="en-US"/>
+          </a:p>
+        </p:txBody>
       </p:sp>
       <p:sp>
         <p:nvSpPr>
@@ -1915,11 +1704,11 @@
           <a:bodyPr wrap="square" rtlCol="0" anchor="ctr"/>
           <a:lstStyle/>
           <a:p>
-            <a:pPr indent="0" marL="0">
-              <a:buNone/>
-            </a:pPr>
-            <a:r>
-              <a:rPr lang="en-US" sz="5200" b="1" spc="100" kern="0" dirty="0">
+            <a:pPr marL="0" indent="0">
+              <a:buNone/>
+            </a:pPr>
+            <a:r>
+              <a:rPr lang="en-US" sz="5200" b="1" kern="0" spc="100" dirty="0">
                 <a:solidFill>
                   <a:srgbClr val="FFFFFF"/>
                 </a:solidFill>
@@ -1954,7 +1743,7 @@
           <a:bodyPr wrap="square" rtlCol="0" anchor="ctr"/>
           <a:lstStyle/>
           <a:p>
-            <a:pPr indent="0" marL="0">
+            <a:pPr marL="0" indent="0">
               <a:buNone/>
             </a:pPr>
             <a:r>
@@ -1993,7 +1782,7 @@
           <a:bodyPr wrap="square" rtlCol="0" anchor="ctr"/>
           <a:lstStyle/>
           <a:p>
-            <a:pPr indent="0" marL="0">
+            <a:pPr marL="0" indent="0">
               <a:buNone/>
             </a:pPr>
             <a:r>
@@ -2032,7 +1821,7 @@
           <a:bodyPr wrap="square" rtlCol="0" anchor="ctr"/>
           <a:lstStyle/>
           <a:p>
-            <a:pPr indent="0" marL="0">
+            <a:pPr marL="0" indent="0">
               <a:buNone/>
             </a:pPr>
             <a:r>
@@ -2046,9 +1835,6 @@
               </a:rPr>
               <a:t>PTA Inkubatsiya 2026</a:t>
             </a:r>
-            <a:pPr indent="0" marL="0">
-              <a:buNone/>
-            </a:pPr>
             <a:r>
               <a:rPr lang="en-US" sz="1300" dirty="0">
                 <a:solidFill>
@@ -2058,7 +1844,7 @@
                 <a:ea typeface="Calibri" pitchFamily="34" charset="-122"/>
                 <a:cs typeface="Calibri" pitchFamily="34" charset="-120"/>
               </a:rPr>
-              <a:t>   ·   Play Store'da jonli   ·   [Jamoa nomi]</a:t>
+              <a:t>  · Hana Group</a:t>
             </a:r>
             <a:endParaRPr lang="en-US" sz="1300" dirty="0"/>
           </a:p>
@@ -2080,6 +1866,7 @@
         <a:solidFill>
           <a:srgbClr val="FFFFFF"/>
         </a:solidFill>
+        <a:effectLst/>
       </p:bgPr>
     </p:bg>
     <p:spTree>
@@ -2117,7 +1904,7 @@
           <a:bodyPr wrap="square" rtlCol="0" anchor="ctr"/>
           <a:lstStyle/>
           <a:p>
-            <a:pPr indent="0" marL="0">
+            <a:pPr marL="0" indent="0">
               <a:buNone/>
             </a:pPr>
             <a:r>
@@ -2156,7 +1943,7 @@
           <a:bodyPr wrap="square" rtlCol="0" anchor="ctr"/>
           <a:lstStyle/>
           <a:p>
-            <a:pPr indent="0" marL="0">
+            <a:pPr marL="0" indent="0">
               <a:buNone/>
             </a:pPr>
             <a:r>
@@ -2200,13 +1987,20 @@
             <a:prstDash val="solid"/>
           </a:ln>
           <a:effectLst>
-            <a:outerShdw sx="100000" sy="100000" kx="0" ky="0" algn="bl" rotWithShape="0" blurRad="101600" dist="25400" dir="5400000">
+            <a:outerShdw blurRad="101600" dist="25400" dir="5400000" algn="bl" rotWithShape="0">
               <a:srgbClr val="B7C3BC">
                 <a:alpha val="35000"/>
               </a:srgbClr>
             </a:outerShdw>
           </a:effectLst>
         </p:spPr>
+        <p:txBody>
+          <a:bodyPr/>
+          <a:lstStyle/>
+          <a:p>
+            <a:endParaRPr lang="ko-KR" altLang="en-US"/>
+          </a:p>
+        </p:txBody>
       </p:sp>
       <p:sp>
         <p:nvSpPr>
@@ -2229,7 +2023,7 @@
           <a:bodyPr wrap="square" rtlCol="0" anchor="ctr"/>
           <a:lstStyle/>
           <a:p>
-            <a:pPr algn="ctr" indent="0" marL="0">
+            <a:pPr marL="0" indent="0" algn="ctr">
               <a:buNone/>
             </a:pPr>
             <a:r>
@@ -2268,7 +2062,7 @@
           <a:bodyPr wrap="square" rtlCol="0" anchor="ctr"/>
           <a:lstStyle/>
           <a:p>
-            <a:pPr algn="ctr" indent="0" marL="0">
+            <a:pPr marL="0" indent="0" algn="ctr">
               <a:buNone/>
             </a:pPr>
             <a:r>
@@ -2312,13 +2106,20 @@
             <a:prstDash val="solid"/>
           </a:ln>
           <a:effectLst>
-            <a:outerShdw sx="100000" sy="100000" kx="0" ky="0" algn="bl" rotWithShape="0" blurRad="101600" dist="25400" dir="5400000">
+            <a:outerShdw blurRad="101600" dist="25400" dir="5400000" algn="bl" rotWithShape="0">
               <a:srgbClr val="B7C3BC">
                 <a:alpha val="35000"/>
               </a:srgbClr>
             </a:outerShdw>
           </a:effectLst>
         </p:spPr>
+        <p:txBody>
+          <a:bodyPr/>
+          <a:lstStyle/>
+          <a:p>
+            <a:endParaRPr lang="ko-KR" altLang="en-US"/>
+          </a:p>
+        </p:txBody>
       </p:sp>
       <p:sp>
         <p:nvSpPr>
@@ -2341,7 +2142,7 @@
           <a:bodyPr wrap="square" rtlCol="0" anchor="ctr"/>
           <a:lstStyle/>
           <a:p>
-            <a:pPr algn="ctr" indent="0" marL="0">
+            <a:pPr marL="0" indent="0" algn="ctr">
               <a:buNone/>
             </a:pPr>
             <a:r>
@@ -2380,7 +2181,7 @@
           <a:bodyPr wrap="square" rtlCol="0" anchor="ctr"/>
           <a:lstStyle/>
           <a:p>
-            <a:pPr algn="ctr" indent="0" marL="0">
+            <a:pPr marL="0" indent="0" algn="ctr">
               <a:buNone/>
             </a:pPr>
             <a:r>
@@ -2424,13 +2225,20 @@
             <a:prstDash val="solid"/>
           </a:ln>
           <a:effectLst>
-            <a:outerShdw sx="100000" sy="100000" kx="0" ky="0" algn="bl" rotWithShape="0" blurRad="101600" dist="25400" dir="5400000">
+            <a:outerShdw blurRad="101600" dist="25400" dir="5400000" algn="bl" rotWithShape="0">
               <a:srgbClr val="B7C3BC">
                 <a:alpha val="35000"/>
               </a:srgbClr>
             </a:outerShdw>
           </a:effectLst>
         </p:spPr>
+        <p:txBody>
+          <a:bodyPr/>
+          <a:lstStyle/>
+          <a:p>
+            <a:endParaRPr lang="ko-KR" altLang="en-US"/>
+          </a:p>
+        </p:txBody>
       </p:sp>
       <p:sp>
         <p:nvSpPr>
@@ -2453,7 +2261,7 @@
           <a:bodyPr wrap="square" rtlCol="0" anchor="ctr"/>
           <a:lstStyle/>
           <a:p>
-            <a:pPr algn="ctr" indent="0" marL="0">
+            <a:pPr marL="0" indent="0" algn="ctr">
               <a:buNone/>
             </a:pPr>
             <a:r>
@@ -2492,7 +2300,7 @@
           <a:bodyPr wrap="square" rtlCol="0" anchor="ctr"/>
           <a:lstStyle/>
           <a:p>
-            <a:pPr algn="ctr" indent="0" marL="0">
+            <a:pPr marL="0" indent="0" algn="ctr">
               <a:buNone/>
             </a:pPr>
             <a:r>
@@ -2536,13 +2344,20 @@
             <a:prstDash val="solid"/>
           </a:ln>
           <a:effectLst>
-            <a:outerShdw sx="100000" sy="100000" kx="0" ky="0" algn="bl" rotWithShape="0" blurRad="101600" dist="25400" dir="5400000">
+            <a:outerShdw blurRad="101600" dist="25400" dir="5400000" algn="bl" rotWithShape="0">
               <a:srgbClr val="B7C3BC">
                 <a:alpha val="35000"/>
               </a:srgbClr>
             </a:outerShdw>
           </a:effectLst>
         </p:spPr>
+        <p:txBody>
+          <a:bodyPr/>
+          <a:lstStyle/>
+          <a:p>
+            <a:endParaRPr lang="ko-KR" altLang="en-US"/>
+          </a:p>
+        </p:txBody>
       </p:sp>
       <p:sp>
         <p:nvSpPr>
@@ -2565,7 +2380,7 @@
           <a:bodyPr wrap="square" rtlCol="0" anchor="ctr"/>
           <a:lstStyle/>
           <a:p>
-            <a:pPr indent="0" marL="0">
+            <a:pPr marL="0" indent="0">
               <a:buNone/>
             </a:pPr>
             <a:r>
@@ -2604,7 +2419,7 @@
           <a:bodyPr wrap="square" rtlCol="0" anchor="ctr"/>
           <a:lstStyle/>
           <a:p>
-            <a:pPr indent="0" marL="0">
+            <a:pPr marL="0" indent="0">
               <a:buNone/>
             </a:pPr>
             <a:r>
@@ -2643,7 +2458,7 @@
           <a:bodyPr wrap="square" rtlCol="0" anchor="ctr"/>
           <a:lstStyle/>
           <a:p>
-            <a:pPr algn="r" indent="0" marL="0">
+            <a:pPr marL="0" indent="0" algn="r">
               <a:buNone/>
             </a:pPr>
             <a:r>
@@ -2677,6 +2492,7 @@
         <a:solidFill>
           <a:srgbClr val="FFFFFF"/>
         </a:solidFill>
+        <a:effectLst/>
       </p:bgPr>
     </p:bg>
     <p:spTree>
@@ -2714,7 +2530,7 @@
           <a:bodyPr wrap="square" rtlCol="0" anchor="ctr"/>
           <a:lstStyle/>
           <a:p>
-            <a:pPr indent="0" marL="0">
+            <a:pPr marL="0" indent="0">
               <a:buNone/>
             </a:pPr>
             <a:r>
@@ -2753,7 +2569,7 @@
           <a:bodyPr wrap="square" rtlCol="0" anchor="ctr"/>
           <a:lstStyle/>
           <a:p>
-            <a:pPr indent="0" marL="0">
+            <a:pPr marL="0" indent="0">
               <a:buNone/>
             </a:pPr>
             <a:r>
@@ -2779,7 +2595,7 @@
         </p:nvSpPr>
         <p:spPr>
           <a:xfrm>
-            <a:off x="640080" y="1965960"/>
+            <a:off x="631534" y="1965960"/>
             <a:ext cx="3566160" cy="365760"/>
           </a:xfrm>
           <a:prstGeom prst="rect">
@@ -2792,7 +2608,7 @@
           <a:bodyPr wrap="square" rtlCol="0" anchor="ctr"/>
           <a:lstStyle/>
           <a:p>
-            <a:pPr indent="0" marL="0">
+            <a:pPr marL="0" indent="0">
               <a:buNone/>
             </a:pPr>
             <a:r>
@@ -2804,7 +2620,29 @@
                 <a:ea typeface="Calibri" pitchFamily="34" charset="-122"/>
                 <a:cs typeface="Calibri" pitchFamily="34" charset="-120"/>
               </a:rPr>
-              <a:t>[Ism] — texnik / CTO</a:t>
+              <a:t>Tursunov Izhorbek — </a:t>
+            </a:r>
+            <a:r>
+              <a:rPr lang="en-US" sz="1300" dirty="0" err="1">
+                <a:solidFill>
+                  <a:srgbClr val="374151"/>
+                </a:solidFill>
+                <a:latin typeface="Calibri" pitchFamily="34" charset="0"/>
+                <a:ea typeface="Calibri" pitchFamily="34" charset="-122"/>
+                <a:cs typeface="Calibri" pitchFamily="34" charset="-120"/>
+              </a:rPr>
+              <a:t>Biznes</a:t>
+            </a:r>
+            <a:r>
+              <a:rPr lang="en-US" sz="1300" dirty="0">
+                <a:solidFill>
+                  <a:srgbClr val="374151"/>
+                </a:solidFill>
+                <a:latin typeface="Calibri" pitchFamily="34" charset="0"/>
+                <a:ea typeface="Calibri" pitchFamily="34" charset="-122"/>
+                <a:cs typeface="Calibri" pitchFamily="34" charset="-120"/>
+              </a:rPr>
+              <a:t> / GTM</a:t>
             </a:r>
             <a:endParaRPr lang="en-US" sz="1300" dirty="0"/>
           </a:p>
@@ -2831,11 +2669,8 @@
           <a:bodyPr wrap="square" rtlCol="0" anchor="ctr"/>
           <a:lstStyle/>
           <a:p>
-            <a:pPr indent="0" marL="0">
-              <a:buNone/>
-            </a:pPr>
-            <a:r>
-              <a:rPr lang="en-US" sz="1300" dirty="0">
+            <a:r>
+              <a:rPr lang="en-US" altLang="ko-KR" sz="1300" dirty="0">
                 <a:solidFill>
                   <a:srgbClr val="374151"/>
                 </a:solidFill>
@@ -2843,9 +2678,53 @@
                 <a:ea typeface="Calibri" pitchFamily="34" charset="-122"/>
                 <a:cs typeface="Calibri" pitchFamily="34" charset="-120"/>
               </a:rPr>
-              <a:t>[Ism] — biznes / GTM</a:t>
-            </a:r>
-            <a:endParaRPr lang="en-US" sz="1300" dirty="0"/>
+              <a:t>Tursunov </a:t>
+            </a:r>
+            <a:r>
+              <a:rPr lang="en-US" altLang="ko-KR" sz="1300" dirty="0" err="1">
+                <a:solidFill>
+                  <a:srgbClr val="374151"/>
+                </a:solidFill>
+                <a:latin typeface="Calibri" pitchFamily="34" charset="0"/>
+                <a:ea typeface="Calibri" pitchFamily="34" charset="-122"/>
+                <a:cs typeface="Calibri" pitchFamily="34" charset="-120"/>
+              </a:rPr>
+              <a:t>Asilbek</a:t>
+            </a:r>
+            <a:r>
+              <a:rPr lang="en-US" altLang="ko-KR" sz="1300" dirty="0">
+                <a:solidFill>
+                  <a:srgbClr val="374151"/>
+                </a:solidFill>
+                <a:latin typeface="Calibri" pitchFamily="34" charset="0"/>
+                <a:ea typeface="Calibri" pitchFamily="34" charset="-122"/>
+                <a:cs typeface="Calibri" pitchFamily="34" charset="-120"/>
+              </a:rPr>
+              <a:t> — </a:t>
+            </a:r>
+            <a:r>
+              <a:rPr lang="en-US" altLang="ko-KR" sz="1300" dirty="0" err="1">
+                <a:solidFill>
+                  <a:srgbClr val="374151"/>
+                </a:solidFill>
+                <a:latin typeface="Calibri" pitchFamily="34" charset="0"/>
+                <a:ea typeface="Calibri" pitchFamily="34" charset="-122"/>
+                <a:cs typeface="Calibri" pitchFamily="34" charset="-120"/>
+              </a:rPr>
+              <a:t>texnik</a:t>
+            </a:r>
+            <a:r>
+              <a:rPr lang="en-US" altLang="ko-KR" sz="1300" dirty="0">
+                <a:solidFill>
+                  <a:srgbClr val="374151"/>
+                </a:solidFill>
+                <a:latin typeface="Calibri" pitchFamily="34" charset="0"/>
+                <a:ea typeface="Calibri" pitchFamily="34" charset="-122"/>
+                <a:cs typeface="Calibri" pitchFamily="34" charset="-120"/>
+              </a:rPr>
+              <a:t> / CTO</a:t>
+            </a:r>
+            <a:endParaRPr lang="en-US" altLang="ko-KR" sz="1300" dirty="0"/>
           </a:p>
         </p:txBody>
       </p:sp>
@@ -2870,7 +2749,7 @@
           <a:bodyPr wrap="square" rtlCol="0" anchor="ctr"/>
           <a:lstStyle/>
           <a:p>
-            <a:pPr indent="0" marL="0">
+            <a:pPr marL="0" indent="0">
               <a:buNone/>
             </a:pPr>
             <a:r>
@@ -2882,7 +2761,51 @@
                 <a:ea typeface="Calibri" pitchFamily="34" charset="-122"/>
                 <a:cs typeface="Calibri" pitchFamily="34" charset="-120"/>
               </a:rPr>
-              <a:t>[Ism] — dizayn / operatsiya</a:t>
+              <a:t>Figma, Claude (</a:t>
+            </a:r>
+            <a:r>
+              <a:rPr lang="en-US" sz="1300" dirty="0" err="1">
+                <a:solidFill>
+                  <a:srgbClr val="374151"/>
+                </a:solidFill>
+                <a:latin typeface="Calibri" pitchFamily="34" charset="0"/>
+                <a:ea typeface="Calibri" pitchFamily="34" charset="-122"/>
+                <a:cs typeface="Calibri" pitchFamily="34" charset="-120"/>
+              </a:rPr>
+              <a:t>pulli</a:t>
+            </a:r>
+            <a:r>
+              <a:rPr lang="en-US" sz="1300" dirty="0">
+                <a:solidFill>
+                  <a:srgbClr val="374151"/>
+                </a:solidFill>
+                <a:latin typeface="Calibri" pitchFamily="34" charset="0"/>
+                <a:ea typeface="Calibri" pitchFamily="34" charset="-122"/>
+                <a:cs typeface="Calibri" pitchFamily="34" charset="-120"/>
+              </a:rPr>
+              <a:t>) — </a:t>
+            </a:r>
+            <a:r>
+              <a:rPr lang="en-US" sz="1300" dirty="0" err="1">
+                <a:solidFill>
+                  <a:srgbClr val="374151"/>
+                </a:solidFill>
+                <a:latin typeface="Calibri" pitchFamily="34" charset="0"/>
+                <a:ea typeface="Calibri" pitchFamily="34" charset="-122"/>
+                <a:cs typeface="Calibri" pitchFamily="34" charset="-120"/>
+              </a:rPr>
+              <a:t>dizayner</a:t>
+            </a:r>
+            <a:r>
+              <a:rPr lang="en-US" sz="1300" dirty="0">
+                <a:solidFill>
+                  <a:srgbClr val="374151"/>
+                </a:solidFill>
+                <a:latin typeface="Calibri" pitchFamily="34" charset="0"/>
+                <a:ea typeface="Calibri" pitchFamily="34" charset="-122"/>
+                <a:cs typeface="Calibri" pitchFamily="34" charset="-120"/>
+              </a:rPr>
+              <a:t> / operatsiya</a:t>
             </a:r>
             <a:endParaRPr lang="en-US" sz="1300" dirty="0"/>
           </a:p>
@@ -2909,7 +2832,7 @@
           <a:bodyPr wrap="square" rtlCol="0" anchor="ctr"/>
           <a:lstStyle/>
           <a:p>
-            <a:pPr indent="0" marL="0">
+            <a:pPr marL="0" indent="0">
               <a:buNone/>
             </a:pPr>
             <a:r>
@@ -2946,6 +2869,13 @@
           </a:solidFill>
           <a:ln/>
         </p:spPr>
+        <p:txBody>
+          <a:bodyPr/>
+          <a:lstStyle/>
+          <a:p>
+            <a:endParaRPr lang="ko-KR" altLang="en-US"/>
+          </a:p>
+        </p:txBody>
       </p:sp>
       <p:sp>
         <p:nvSpPr>
@@ -2968,7 +2898,7 @@
           <a:bodyPr wrap="square" rtlCol="0" anchor="ctr"/>
           <a:lstStyle/>
           <a:p>
-            <a:pPr algn="ctr" indent="0" marL="0">
+            <a:pPr marL="0" indent="0" algn="ctr">
               <a:buNone/>
             </a:pPr>
             <a:r>
@@ -3007,7 +2937,7 @@
           <a:bodyPr wrap="square" rtlCol="0" anchor="ctr"/>
           <a:lstStyle/>
           <a:p>
-            <a:pPr indent="0" marL="0">
+            <a:pPr marL="0" indent="0">
               <a:buNone/>
             </a:pPr>
             <a:r>
@@ -3044,6 +2974,13 @@
           </a:solidFill>
           <a:ln/>
         </p:spPr>
+        <p:txBody>
+          <a:bodyPr/>
+          <a:lstStyle/>
+          <a:p>
+            <a:endParaRPr lang="ko-KR" altLang="en-US"/>
+          </a:p>
+        </p:txBody>
       </p:sp>
       <p:sp>
         <p:nvSpPr>
@@ -3066,7 +3003,7 @@
           <a:bodyPr wrap="square" rtlCol="0" anchor="ctr"/>
           <a:lstStyle/>
           <a:p>
-            <a:pPr algn="ctr" indent="0" marL="0">
+            <a:pPr marL="0" indent="0" algn="ctr">
               <a:buNone/>
             </a:pPr>
             <a:r>
@@ -3105,7 +3042,7 @@
           <a:bodyPr wrap="square" rtlCol="0" anchor="ctr"/>
           <a:lstStyle/>
           <a:p>
-            <a:pPr indent="0" marL="0">
+            <a:pPr marL="0" indent="0">
               <a:buNone/>
             </a:pPr>
             <a:r>
@@ -3142,6 +3079,13 @@
           </a:solidFill>
           <a:ln/>
         </p:spPr>
+        <p:txBody>
+          <a:bodyPr/>
+          <a:lstStyle/>
+          <a:p>
+            <a:endParaRPr lang="ko-KR" altLang="en-US"/>
+          </a:p>
+        </p:txBody>
       </p:sp>
       <p:sp>
         <p:nvSpPr>
@@ -3164,7 +3108,7 @@
           <a:bodyPr wrap="square" rtlCol="0" anchor="ctr"/>
           <a:lstStyle/>
           <a:p>
-            <a:pPr algn="ctr" indent="0" marL="0">
+            <a:pPr marL="0" indent="0" algn="ctr">
               <a:buNone/>
             </a:pPr>
             <a:r>
@@ -3203,7 +3147,7 @@
           <a:bodyPr wrap="square" rtlCol="0" anchor="ctr"/>
           <a:lstStyle/>
           <a:p>
-            <a:pPr indent="0" marL="0">
+            <a:pPr marL="0" indent="0">
               <a:buNone/>
             </a:pPr>
             <a:r>
@@ -3240,6 +3184,13 @@
           </a:solidFill>
           <a:ln/>
         </p:spPr>
+        <p:txBody>
+          <a:bodyPr/>
+          <a:lstStyle/>
+          <a:p>
+            <a:endParaRPr lang="ko-KR" altLang="en-US"/>
+          </a:p>
+        </p:txBody>
       </p:sp>
       <p:sp>
         <p:nvSpPr>
@@ -3262,7 +3213,7 @@
           <a:bodyPr wrap="square" rtlCol="0" anchor="ctr"/>
           <a:lstStyle/>
           <a:p>
-            <a:pPr algn="ctr" indent="0" marL="0">
+            <a:pPr marL="0" indent="0" algn="ctr">
               <a:buNone/>
             </a:pPr>
             <a:r>
@@ -3301,7 +3252,7 @@
           <a:bodyPr wrap="square" rtlCol="0" anchor="ctr"/>
           <a:lstStyle/>
           <a:p>
-            <a:pPr indent="0" marL="0">
+            <a:pPr marL="0" indent="0">
               <a:buNone/>
             </a:pPr>
             <a:r>
@@ -3340,7 +3291,7 @@
           <a:bodyPr wrap="square" rtlCol="0" anchor="ctr"/>
           <a:lstStyle/>
           <a:p>
-            <a:pPr indent="0" marL="0">
+            <a:pPr marL="0" indent="0">
               <a:buNone/>
             </a:pPr>
             <a:r>
@@ -3377,6 +3328,13 @@
           </a:solidFill>
           <a:ln/>
         </p:spPr>
+        <p:txBody>
+          <a:bodyPr/>
+          <a:lstStyle/>
+          <a:p>
+            <a:endParaRPr lang="ko-KR" altLang="en-US"/>
+          </a:p>
+        </p:txBody>
       </p:sp>
       <p:sp>
         <p:nvSpPr>
@@ -3399,7 +3357,7 @@
           <a:bodyPr wrap="square" rtlCol="0" anchor="ctr"/>
           <a:lstStyle/>
           <a:p>
-            <a:pPr algn="ctr" indent="0" marL="0">
+            <a:pPr marL="0" indent="0" algn="ctr">
               <a:buNone/>
             </a:pPr>
             <a:r>
@@ -3438,7 +3396,7 @@
           <a:bodyPr wrap="square" rtlCol="0" anchor="ctr"/>
           <a:lstStyle/>
           <a:p>
-            <a:pPr indent="0" marL="0">
+            <a:pPr marL="0" indent="0">
               <a:buNone/>
             </a:pPr>
             <a:r>
@@ -3477,7 +3435,7 @@
           <a:bodyPr wrap="square" rtlCol="0" anchor="ctr"/>
           <a:lstStyle/>
           <a:p>
-            <a:pPr indent="0" marL="0">
+            <a:pPr marL="0" indent="0">
               <a:buNone/>
             </a:pPr>
             <a:r>
@@ -3514,6 +3472,13 @@
           </a:solidFill>
           <a:ln/>
         </p:spPr>
+        <p:txBody>
+          <a:bodyPr/>
+          <a:lstStyle/>
+          <a:p>
+            <a:endParaRPr lang="ko-KR" altLang="en-US"/>
+          </a:p>
+        </p:txBody>
       </p:sp>
       <p:sp>
         <p:nvSpPr>
@@ -3536,7 +3501,7 @@
           <a:bodyPr wrap="square" rtlCol="0" anchor="ctr"/>
           <a:lstStyle/>
           <a:p>
-            <a:pPr algn="ctr" indent="0" marL="0">
+            <a:pPr marL="0" indent="0" algn="ctr">
               <a:buNone/>
             </a:pPr>
             <a:r>
@@ -3575,7 +3540,7 @@
           <a:bodyPr wrap="square" rtlCol="0" anchor="ctr"/>
           <a:lstStyle/>
           <a:p>
-            <a:pPr indent="0" marL="0">
+            <a:pPr marL="0" indent="0">
               <a:buNone/>
             </a:pPr>
             <a:r>
@@ -3614,7 +3579,7 @@
           <a:bodyPr wrap="square" rtlCol="0" anchor="ctr"/>
           <a:lstStyle/>
           <a:p>
-            <a:pPr indent="0" marL="0">
+            <a:pPr marL="0" indent="0">
               <a:buNone/>
             </a:pPr>
             <a:r>
@@ -3651,6 +3616,13 @@
           </a:solidFill>
           <a:ln/>
         </p:spPr>
+        <p:txBody>
+          <a:bodyPr/>
+          <a:lstStyle/>
+          <a:p>
+            <a:endParaRPr lang="ko-KR" altLang="en-US"/>
+          </a:p>
+        </p:txBody>
       </p:sp>
       <p:sp>
         <p:nvSpPr>
@@ -3673,7 +3645,7 @@
           <a:bodyPr wrap="square" rtlCol="0" anchor="ctr"/>
           <a:lstStyle/>
           <a:p>
-            <a:pPr algn="ctr" indent="0" marL="0">
+            <a:pPr marL="0" indent="0" algn="ctr">
               <a:buNone/>
             </a:pPr>
             <a:r>
@@ -3712,7 +3684,7 @@
           <a:bodyPr wrap="square" rtlCol="0" anchor="ctr"/>
           <a:lstStyle/>
           <a:p>
-            <a:pPr indent="0" marL="0">
+            <a:pPr marL="0" indent="0">
               <a:buNone/>
             </a:pPr>
             <a:r>
@@ -3751,7 +3723,7 @@
           <a:bodyPr wrap="square" rtlCol="0" anchor="ctr"/>
           <a:lstStyle/>
           <a:p>
-            <a:pPr indent="0" marL="0">
+            <a:pPr marL="0" indent="0">
               <a:buNone/>
             </a:pPr>
             <a:r>
@@ -3795,13 +3767,20 @@
             <a:prstDash val="solid"/>
           </a:ln>
           <a:effectLst>
-            <a:outerShdw sx="100000" sy="100000" kx="0" ky="0" algn="bl" rotWithShape="0" blurRad="101600" dist="25400" dir="5400000">
+            <a:outerShdw blurRad="101600" dist="25400" dir="5400000" algn="bl" rotWithShape="0">
               <a:srgbClr val="B7C3BC">
                 <a:alpha val="35000"/>
               </a:srgbClr>
             </a:outerShdw>
           </a:effectLst>
         </p:spPr>
+        <p:txBody>
+          <a:bodyPr/>
+          <a:lstStyle/>
+          <a:p>
+            <a:endParaRPr lang="ko-KR" altLang="en-US"/>
+          </a:p>
+        </p:txBody>
       </p:sp>
       <p:sp>
         <p:nvSpPr>
@@ -3824,7 +3803,7 @@
           <a:bodyPr wrap="square" rtlCol="0" anchor="ctr"/>
           <a:lstStyle/>
           <a:p>
-            <a:pPr indent="0" marL="0">
+            <a:pPr marL="0" indent="0">
               <a:buNone/>
             </a:pPr>
             <a:r>
@@ -3863,7 +3842,7 @@
           <a:bodyPr wrap="square" rtlCol="0" anchor="ctr"/>
           <a:lstStyle/>
           <a:p>
-            <a:pPr algn="r" indent="0" marL="0">
+            <a:pPr marL="0" indent="0" algn="r">
               <a:buNone/>
             </a:pPr>
             <a:r>
@@ -3897,6 +3876,7 @@
         <a:solidFill>
           <a:srgbClr val="0F1E16"/>
         </a:solidFill>
+        <a:effectLst/>
       </p:bgPr>
     </p:bg>
     <p:spTree>
@@ -3932,6 +3912,13 @@
           </a:solidFill>
           <a:ln/>
         </p:spPr>
+        <p:txBody>
+          <a:bodyPr/>
+          <a:lstStyle/>
+          <a:p>
+            <a:endParaRPr lang="ko-KR" altLang="en-US"/>
+          </a:p>
+        </p:txBody>
       </p:sp>
       <p:sp>
         <p:nvSpPr>
@@ -3952,6 +3939,13 @@
           </a:solidFill>
           <a:ln/>
         </p:spPr>
+        <p:txBody>
+          <a:bodyPr/>
+          <a:lstStyle/>
+          <a:p>
+            <a:endParaRPr lang="ko-KR" altLang="en-US"/>
+          </a:p>
+        </p:txBody>
       </p:sp>
       <p:sp>
         <p:nvSpPr>
@@ -3974,7 +3968,7 @@
           <a:bodyPr wrap="square" rtlCol="0" anchor="ctr"/>
           <a:lstStyle/>
           <a:p>
-            <a:pPr indent="0" marL="0">
+            <a:pPr marL="0" indent="0">
               <a:buNone/>
             </a:pPr>
             <a:r>
@@ -3986,7 +3980,7 @@
                 <a:ea typeface="Calibri" pitchFamily="34" charset="-122"/>
                 <a:cs typeface="Calibri" pitchFamily="34" charset="-120"/>
               </a:rPr>
-              <a:t>Bitta mahalladan —</a:t>
+              <a:t>Bir mahalladan —</a:t>
             </a:r>
             <a:endParaRPr lang="en-US" sz="3000" dirty="0"/>
           </a:p>
@@ -4013,7 +4007,7 @@
           <a:bodyPr wrap="square" rtlCol="0" anchor="ctr"/>
           <a:lstStyle/>
           <a:p>
-            <a:pPr indent="0" marL="0">
+            <a:pPr marL="0" indent="0">
               <a:buNone/>
             </a:pPr>
             <a:r>
@@ -4052,7 +4046,7 @@
           <a:bodyPr wrap="square" rtlCol="0" anchor="ctr"/>
           <a:lstStyle/>
           <a:p>
-            <a:pPr indent="0" marL="0">
+            <a:pPr marL="0" indent="0">
               <a:buNone/>
             </a:pPr>
             <a:r>
@@ -4091,11 +4085,11 @@
           <a:bodyPr wrap="square" rtlCol="0" anchor="ctr"/>
           <a:lstStyle/>
           <a:p>
-            <a:pPr indent="0" marL="0">
-              <a:buNone/>
-            </a:pPr>
-            <a:r>
-              <a:rPr lang="en-US" sz="1400" b="1" spc="100" kern="0" dirty="0">
+            <a:pPr marL="0" indent="0">
+              <a:buNone/>
+            </a:pPr>
+            <a:r>
+              <a:rPr lang="en-US" sz="1400" b="1" kern="0" spc="100" dirty="0">
                 <a:solidFill>
                   <a:srgbClr val="FFFFFF"/>
                 </a:solidFill>
@@ -4125,6 +4119,7 @@
         <a:solidFill>
           <a:srgbClr val="FFFFFF"/>
         </a:solidFill>
+        <a:effectLst/>
       </p:bgPr>
     </p:bg>
     <p:spTree>
@@ -4162,7 +4157,7 @@
           <a:bodyPr wrap="square" rtlCol="0" anchor="ctr"/>
           <a:lstStyle/>
           <a:p>
-            <a:pPr indent="0" marL="0">
+            <a:pPr marL="0" indent="0">
               <a:buNone/>
             </a:pPr>
             <a:r>
@@ -4201,7 +4196,7 @@
           <a:bodyPr wrap="square" rtlCol="0" anchor="ctr"/>
           <a:lstStyle/>
           <a:p>
-            <a:pPr indent="0" marL="0">
+            <a:pPr marL="0" indent="0">
               <a:buNone/>
             </a:pPr>
             <a:r>
@@ -4238,6 +4233,13 @@
           </a:solidFill>
           <a:ln/>
         </p:spPr>
+        <p:txBody>
+          <a:bodyPr/>
+          <a:lstStyle/>
+          <a:p>
+            <a:endParaRPr lang="ko-KR" altLang="en-US"/>
+          </a:p>
+        </p:txBody>
       </p:sp>
       <p:sp>
         <p:nvSpPr>
@@ -4260,7 +4262,7 @@
           <a:bodyPr wrap="square" rtlCol="0" anchor="ctr"/>
           <a:lstStyle/>
           <a:p>
-            <a:pPr algn="ctr" indent="0" marL="0">
+            <a:pPr marL="0" indent="0" algn="ctr">
               <a:buNone/>
             </a:pPr>
             <a:r>
@@ -4299,7 +4301,7 @@
           <a:bodyPr wrap="square" rtlCol="0" anchor="ctr"/>
           <a:lstStyle/>
           <a:p>
-            <a:pPr indent="0" marL="0">
+            <a:pPr marL="0" indent="0">
               <a:buNone/>
             </a:pPr>
             <a:r>
@@ -4338,7 +4340,7 @@
           <a:bodyPr wrap="square" rtlCol="0" anchor="ctr"/>
           <a:lstStyle/>
           <a:p>
-            <a:pPr indent="0" marL="0">
+            <a:pPr marL="0" indent="0">
               <a:buNone/>
             </a:pPr>
             <a:r>
@@ -4375,6 +4377,13 @@
           </a:solidFill>
           <a:ln/>
         </p:spPr>
+        <p:txBody>
+          <a:bodyPr/>
+          <a:lstStyle/>
+          <a:p>
+            <a:endParaRPr lang="ko-KR" altLang="en-US"/>
+          </a:p>
+        </p:txBody>
       </p:sp>
       <p:sp>
         <p:nvSpPr>
@@ -4397,7 +4406,7 @@
           <a:bodyPr wrap="square" rtlCol="0" anchor="ctr"/>
           <a:lstStyle/>
           <a:p>
-            <a:pPr algn="ctr" indent="0" marL="0">
+            <a:pPr marL="0" indent="0" algn="ctr">
               <a:buNone/>
             </a:pPr>
             <a:r>
@@ -4436,7 +4445,7 @@
           <a:bodyPr wrap="square" rtlCol="0" anchor="ctr"/>
           <a:lstStyle/>
           <a:p>
-            <a:pPr indent="0" marL="0">
+            <a:pPr marL="0" indent="0">
               <a:buNone/>
             </a:pPr>
             <a:r>
@@ -4475,7 +4484,7 @@
           <a:bodyPr wrap="square" rtlCol="0" anchor="ctr"/>
           <a:lstStyle/>
           <a:p>
-            <a:pPr indent="0" marL="0">
+            <a:pPr marL="0" indent="0">
               <a:buNone/>
             </a:pPr>
             <a:r>
@@ -4512,6 +4521,13 @@
           </a:solidFill>
           <a:ln/>
         </p:spPr>
+        <p:txBody>
+          <a:bodyPr/>
+          <a:lstStyle/>
+          <a:p>
+            <a:endParaRPr lang="ko-KR" altLang="en-US"/>
+          </a:p>
+        </p:txBody>
       </p:sp>
       <p:sp>
         <p:nvSpPr>
@@ -4534,7 +4550,7 @@
           <a:bodyPr wrap="square" rtlCol="0" anchor="ctr"/>
           <a:lstStyle/>
           <a:p>
-            <a:pPr algn="ctr" indent="0" marL="0">
+            <a:pPr marL="0" indent="0" algn="ctr">
               <a:buNone/>
             </a:pPr>
             <a:r>
@@ -4573,7 +4589,7 @@
           <a:bodyPr wrap="square" rtlCol="0" anchor="ctr"/>
           <a:lstStyle/>
           <a:p>
-            <a:pPr indent="0" marL="0">
+            <a:pPr marL="0" indent="0">
               <a:buNone/>
             </a:pPr>
             <a:r>
@@ -4612,7 +4628,7 @@
           <a:bodyPr wrap="square" rtlCol="0" anchor="ctr"/>
           <a:lstStyle/>
           <a:p>
-            <a:pPr indent="0" marL="0">
+            <a:pPr marL="0" indent="0">
               <a:buNone/>
             </a:pPr>
             <a:r>
@@ -4649,6 +4665,13 @@
           </a:solidFill>
           <a:ln/>
         </p:spPr>
+        <p:txBody>
+          <a:bodyPr/>
+          <a:lstStyle/>
+          <a:p>
+            <a:endParaRPr lang="ko-KR" altLang="en-US"/>
+          </a:p>
+        </p:txBody>
       </p:sp>
       <p:sp>
         <p:nvSpPr>
@@ -4671,7 +4694,7 @@
           <a:bodyPr wrap="square" rtlCol="0" anchor="ctr"/>
           <a:lstStyle/>
           <a:p>
-            <a:pPr algn="ctr" indent="0" marL="0">
+            <a:pPr marL="0" indent="0" algn="ctr">
               <a:buNone/>
             </a:pPr>
             <a:r>
@@ -4710,7 +4733,7 @@
           <a:bodyPr wrap="square" rtlCol="0" anchor="ctr"/>
           <a:lstStyle/>
           <a:p>
-            <a:pPr indent="0" marL="0">
+            <a:pPr marL="0" indent="0">
               <a:buNone/>
             </a:pPr>
             <a:r>
@@ -4749,7 +4772,7 @@
           <a:bodyPr wrap="square" rtlCol="0" anchor="ctr"/>
           <a:lstStyle/>
           <a:p>
-            <a:pPr indent="0" marL="0">
+            <a:pPr marL="0" indent="0">
               <a:buNone/>
             </a:pPr>
             <a:r>
@@ -4788,7 +4811,7 @@
           <a:bodyPr wrap="square" rtlCol="0" anchor="ctr"/>
           <a:lstStyle/>
           <a:p>
-            <a:pPr indent="0" marL="0">
+            <a:pPr marL="0" indent="0">
               <a:buNone/>
             </a:pPr>
             <a:r>
@@ -4827,7 +4850,7 @@
           <a:bodyPr wrap="square" rtlCol="0" anchor="ctr"/>
           <a:lstStyle/>
           <a:p>
-            <a:pPr algn="r" indent="0" marL="0">
+            <a:pPr marL="0" indent="0" algn="r">
               <a:buNone/>
             </a:pPr>
             <a:r>
@@ -4861,6 +4884,7 @@
         <a:solidFill>
           <a:srgbClr val="FFFFFF"/>
         </a:solidFill>
+        <a:effectLst/>
       </p:bgPr>
     </p:bg>
     <p:spTree>
@@ -4898,7 +4922,7 @@
           <a:bodyPr wrap="square" rtlCol="0" anchor="ctr"/>
           <a:lstStyle/>
           <a:p>
-            <a:pPr indent="0" marL="0">
+            <a:pPr marL="0" indent="0">
               <a:buNone/>
             </a:pPr>
             <a:r>
@@ -4937,7 +4961,7 @@
           <a:bodyPr wrap="square" rtlCol="0" anchor="ctr"/>
           <a:lstStyle/>
           <a:p>
-            <a:pPr indent="0" marL="0">
+            <a:pPr marL="0" indent="0">
               <a:buNone/>
             </a:pPr>
             <a:r>
@@ -4981,13 +5005,20 @@
             <a:prstDash val="solid"/>
           </a:ln>
           <a:effectLst>
-            <a:outerShdw sx="100000" sy="100000" kx="0" ky="0" algn="bl" rotWithShape="0" blurRad="101600" dist="25400" dir="5400000">
+            <a:outerShdw blurRad="101600" dist="25400" dir="5400000" algn="bl" rotWithShape="0">
               <a:srgbClr val="B7C3BC">
                 <a:alpha val="35000"/>
               </a:srgbClr>
             </a:outerShdw>
           </a:effectLst>
         </p:spPr>
+        <p:txBody>
+          <a:bodyPr/>
+          <a:lstStyle/>
+          <a:p>
+            <a:endParaRPr lang="ko-KR" altLang="en-US"/>
+          </a:p>
+        </p:txBody>
       </p:sp>
       <p:sp>
         <p:nvSpPr>
@@ -5008,6 +5039,13 @@
           </a:solidFill>
           <a:ln/>
         </p:spPr>
+        <p:txBody>
+          <a:bodyPr/>
+          <a:lstStyle/>
+          <a:p>
+            <a:endParaRPr lang="ko-KR" altLang="en-US"/>
+          </a:p>
+        </p:txBody>
       </p:sp>
       <p:sp>
         <p:nvSpPr>
@@ -5030,7 +5068,7 @@
           <a:bodyPr wrap="square" rtlCol="0" anchor="ctr"/>
           <a:lstStyle/>
           <a:p>
-            <a:pPr algn="ctr" indent="0" marL="0">
+            <a:pPr marL="0" indent="0" algn="ctr">
               <a:buNone/>
             </a:pPr>
             <a:r>
@@ -5069,7 +5107,7 @@
           <a:bodyPr wrap="square" rtlCol="0" anchor="ctr"/>
           <a:lstStyle/>
           <a:p>
-            <a:pPr algn="ctr" indent="0" marL="0">
+            <a:pPr marL="0" indent="0" algn="ctr">
               <a:buNone/>
             </a:pPr>
             <a:r>
@@ -5108,7 +5146,7 @@
           <a:bodyPr wrap="square" rtlCol="0" anchor="ctr"/>
           <a:lstStyle/>
           <a:p>
-            <a:pPr algn="ctr" indent="0" marL="0">
+            <a:pPr marL="0" indent="0" algn="ctr">
               <a:buNone/>
             </a:pPr>
             <a:r>
@@ -5152,13 +5190,20 @@
             <a:prstDash val="solid"/>
           </a:ln>
           <a:effectLst>
-            <a:outerShdw sx="100000" sy="100000" kx="0" ky="0" algn="bl" rotWithShape="0" blurRad="101600" dist="25400" dir="5400000">
+            <a:outerShdw blurRad="101600" dist="25400" dir="5400000" algn="bl" rotWithShape="0">
               <a:srgbClr val="B7C3BC">
                 <a:alpha val="35000"/>
               </a:srgbClr>
             </a:outerShdw>
           </a:effectLst>
         </p:spPr>
+        <p:txBody>
+          <a:bodyPr/>
+          <a:lstStyle/>
+          <a:p>
+            <a:endParaRPr lang="ko-KR" altLang="en-US"/>
+          </a:p>
+        </p:txBody>
       </p:sp>
       <p:sp>
         <p:nvSpPr>
@@ -5179,6 +5224,13 @@
           </a:solidFill>
           <a:ln/>
         </p:spPr>
+        <p:txBody>
+          <a:bodyPr/>
+          <a:lstStyle/>
+          <a:p>
+            <a:endParaRPr lang="ko-KR" altLang="en-US"/>
+          </a:p>
+        </p:txBody>
       </p:sp>
       <p:sp>
         <p:nvSpPr>
@@ -5201,7 +5253,7 @@
           <a:bodyPr wrap="square" rtlCol="0" anchor="ctr"/>
           <a:lstStyle/>
           <a:p>
-            <a:pPr algn="ctr" indent="0" marL="0">
+            <a:pPr marL="0" indent="0" algn="ctr">
               <a:buNone/>
             </a:pPr>
             <a:r>
@@ -5240,7 +5292,7 @@
           <a:bodyPr wrap="square" rtlCol="0" anchor="ctr"/>
           <a:lstStyle/>
           <a:p>
-            <a:pPr algn="ctr" indent="0" marL="0">
+            <a:pPr marL="0" indent="0" algn="ctr">
               <a:buNone/>
             </a:pPr>
             <a:r>
@@ -5279,7 +5331,7 @@
           <a:bodyPr wrap="square" rtlCol="0" anchor="ctr"/>
           <a:lstStyle/>
           <a:p>
-            <a:pPr algn="ctr" indent="0" marL="0">
+            <a:pPr marL="0" indent="0" algn="ctr">
               <a:buNone/>
             </a:pPr>
             <a:r>
@@ -5323,13 +5375,20 @@
             <a:prstDash val="solid"/>
           </a:ln>
           <a:effectLst>
-            <a:outerShdw sx="100000" sy="100000" kx="0" ky="0" algn="bl" rotWithShape="0" blurRad="101600" dist="25400" dir="5400000">
+            <a:outerShdw blurRad="101600" dist="25400" dir="5400000" algn="bl" rotWithShape="0">
               <a:srgbClr val="B7C3BC">
                 <a:alpha val="35000"/>
               </a:srgbClr>
             </a:outerShdw>
           </a:effectLst>
         </p:spPr>
+        <p:txBody>
+          <a:bodyPr/>
+          <a:lstStyle/>
+          <a:p>
+            <a:endParaRPr lang="ko-KR" altLang="en-US"/>
+          </a:p>
+        </p:txBody>
       </p:sp>
       <p:sp>
         <p:nvSpPr>
@@ -5350,6 +5409,13 @@
           </a:solidFill>
           <a:ln/>
         </p:spPr>
+        <p:txBody>
+          <a:bodyPr/>
+          <a:lstStyle/>
+          <a:p>
+            <a:endParaRPr lang="ko-KR" altLang="en-US"/>
+          </a:p>
+        </p:txBody>
       </p:sp>
       <p:sp>
         <p:nvSpPr>
@@ -5372,7 +5438,7 @@
           <a:bodyPr wrap="square" rtlCol="0" anchor="ctr"/>
           <a:lstStyle/>
           <a:p>
-            <a:pPr algn="ctr" indent="0" marL="0">
+            <a:pPr marL="0" indent="0" algn="ctr">
               <a:buNone/>
             </a:pPr>
             <a:r>
@@ -5411,7 +5477,7 @@
           <a:bodyPr wrap="square" rtlCol="0" anchor="ctr"/>
           <a:lstStyle/>
           <a:p>
-            <a:pPr algn="ctr" indent="0" marL="0">
+            <a:pPr marL="0" indent="0" algn="ctr">
               <a:buNone/>
             </a:pPr>
             <a:r>
@@ -5450,7 +5516,7 @@
           <a:bodyPr wrap="square" rtlCol="0" anchor="ctr"/>
           <a:lstStyle/>
           <a:p>
-            <a:pPr algn="ctr" indent="0" marL="0">
+            <a:pPr marL="0" indent="0" algn="ctr">
               <a:buNone/>
             </a:pPr>
             <a:r>
@@ -5494,13 +5560,20 @@
             <a:prstDash val="solid"/>
           </a:ln>
           <a:effectLst>
-            <a:outerShdw sx="100000" sy="100000" kx="0" ky="0" algn="bl" rotWithShape="0" blurRad="101600" dist="25400" dir="5400000">
+            <a:outerShdw blurRad="101600" dist="25400" dir="5400000" algn="bl" rotWithShape="0">
               <a:srgbClr val="B7C3BC">
                 <a:alpha val="35000"/>
               </a:srgbClr>
             </a:outerShdw>
           </a:effectLst>
         </p:spPr>
+        <p:txBody>
+          <a:bodyPr/>
+          <a:lstStyle/>
+          <a:p>
+            <a:endParaRPr lang="ko-KR" altLang="en-US"/>
+          </a:p>
+        </p:txBody>
       </p:sp>
       <p:sp>
         <p:nvSpPr>
@@ -5521,6 +5594,13 @@
           </a:solidFill>
           <a:ln/>
         </p:spPr>
+        <p:txBody>
+          <a:bodyPr/>
+          <a:lstStyle/>
+          <a:p>
+            <a:endParaRPr lang="ko-KR" altLang="en-US"/>
+          </a:p>
+        </p:txBody>
       </p:sp>
       <p:sp>
         <p:nvSpPr>
@@ -5543,7 +5623,7 @@
           <a:bodyPr wrap="square" rtlCol="0" anchor="ctr"/>
           <a:lstStyle/>
           <a:p>
-            <a:pPr algn="ctr" indent="0" marL="0">
+            <a:pPr marL="0" indent="0" algn="ctr">
               <a:buNone/>
             </a:pPr>
             <a:r>
@@ -5582,7 +5662,7 @@
           <a:bodyPr wrap="square" rtlCol="0" anchor="ctr"/>
           <a:lstStyle/>
           <a:p>
-            <a:pPr algn="ctr" indent="0" marL="0">
+            <a:pPr marL="0" indent="0" algn="ctr">
               <a:buNone/>
             </a:pPr>
             <a:r>
@@ -5621,7 +5701,7 @@
           <a:bodyPr wrap="square" rtlCol="0" anchor="ctr"/>
           <a:lstStyle/>
           <a:p>
-            <a:pPr algn="ctr" indent="0" marL="0">
+            <a:pPr marL="0" indent="0" algn="ctr">
               <a:buNone/>
             </a:pPr>
             <a:r>
@@ -5665,13 +5745,20 @@
             <a:prstDash val="solid"/>
           </a:ln>
           <a:effectLst>
-            <a:outerShdw sx="100000" sy="100000" kx="0" ky="0" algn="bl" rotWithShape="0" blurRad="101600" dist="25400" dir="5400000">
+            <a:outerShdw blurRad="101600" dist="25400" dir="5400000" algn="bl" rotWithShape="0">
               <a:srgbClr val="B7C3BC">
                 <a:alpha val="35000"/>
               </a:srgbClr>
             </a:outerShdw>
           </a:effectLst>
         </p:spPr>
+        <p:txBody>
+          <a:bodyPr/>
+          <a:lstStyle/>
+          <a:p>
+            <a:endParaRPr lang="ko-KR" altLang="en-US"/>
+          </a:p>
+        </p:txBody>
       </p:sp>
       <p:sp>
         <p:nvSpPr>
@@ -5692,6 +5779,13 @@
           </a:solidFill>
           <a:ln/>
         </p:spPr>
+        <p:txBody>
+          <a:bodyPr/>
+          <a:lstStyle/>
+          <a:p>
+            <a:endParaRPr lang="ko-KR" altLang="en-US"/>
+          </a:p>
+        </p:txBody>
       </p:sp>
       <p:sp>
         <p:nvSpPr>
@@ -5714,7 +5808,7 @@
           <a:bodyPr wrap="square" rtlCol="0" anchor="ctr"/>
           <a:lstStyle/>
           <a:p>
-            <a:pPr algn="ctr" indent="0" marL="0">
+            <a:pPr marL="0" indent="0" algn="ctr">
               <a:buNone/>
             </a:pPr>
             <a:r>
@@ -5753,7 +5847,7 @@
           <a:bodyPr wrap="square" rtlCol="0" anchor="ctr"/>
           <a:lstStyle/>
           <a:p>
-            <a:pPr algn="ctr" indent="0" marL="0">
+            <a:pPr marL="0" indent="0" algn="ctr">
               <a:buNone/>
             </a:pPr>
             <a:r>
@@ -5792,7 +5886,7 @@
           <a:bodyPr wrap="square" rtlCol="0" anchor="ctr"/>
           <a:lstStyle/>
           <a:p>
-            <a:pPr algn="ctr" indent="0" marL="0">
+            <a:pPr marL="0" indent="0" algn="ctr">
               <a:buNone/>
             </a:pPr>
             <a:r>
@@ -5836,13 +5930,20 @@
             <a:prstDash val="solid"/>
           </a:ln>
           <a:effectLst>
-            <a:outerShdw sx="100000" sy="100000" kx="0" ky="0" algn="bl" rotWithShape="0" blurRad="101600" dist="25400" dir="5400000">
+            <a:outerShdw blurRad="101600" dist="25400" dir="5400000" algn="bl" rotWithShape="0">
               <a:srgbClr val="B7C3BC">
                 <a:alpha val="35000"/>
               </a:srgbClr>
             </a:outerShdw>
           </a:effectLst>
         </p:spPr>
+        <p:txBody>
+          <a:bodyPr/>
+          <a:lstStyle/>
+          <a:p>
+            <a:endParaRPr lang="ko-KR" altLang="en-US"/>
+          </a:p>
+        </p:txBody>
       </p:sp>
       <p:sp>
         <p:nvSpPr>
@@ -5865,7 +5966,7 @@
           <a:bodyPr wrap="square" rtlCol="0" anchor="ctr"/>
           <a:lstStyle/>
           <a:p>
-            <a:pPr indent="0" marL="0">
+            <a:pPr marL="0" indent="0">
               <a:buNone/>
             </a:pPr>
             <a:r>
@@ -5879,9 +5980,6 @@
               </a:rPr>
               <a:t>Farqi: </a:t>
             </a:r>
-            <a:pPr indent="0" marL="0">
-              <a:buNone/>
-            </a:pPr>
             <a:r>
               <a:rPr lang="en-US" sz="1500" dirty="0">
                 <a:solidFill>
@@ -5893,9 +5991,6 @@
               </a:rPr>
               <a:t>raqobatchilar faqat </a:t>
             </a:r>
-            <a:pPr indent="0" marL="0">
-              <a:buNone/>
-            </a:pPr>
             <a:r>
               <a:rPr lang="en-US" sz="1500" b="1" dirty="0">
                 <a:solidFill>
@@ -5907,9 +6002,6 @@
               </a:rPr>
               <a:t>savdoni</a:t>
             </a:r>
-            <a:pPr indent="0" marL="0">
-              <a:buNone/>
-            </a:pPr>
             <a:r>
               <a:rPr lang="en-US" sz="1500" dirty="0">
                 <a:solidFill>
@@ -5921,9 +6013,6 @@
               </a:rPr>
               <a:t> (past chastota) qamraydi. Hana Market — savdo </a:t>
             </a:r>
-            <a:pPr indent="0" marL="0">
-              <a:buNone/>
-            </a:pPr>
             <a:r>
               <a:rPr lang="en-US" sz="1500" b="1" dirty="0">
                 <a:solidFill>
@@ -5935,9 +6024,6 @@
               </a:rPr>
               <a:t>+ yuqori chastotali mahalla ma'lumoti/xizmati/gaz</a:t>
             </a:r>
-            <a:pPr indent="0" marL="0">
-              <a:buNone/>
-            </a:pPr>
             <a:r>
               <a:rPr lang="en-US" sz="1500" dirty="0">
                 <a:solidFill>
@@ -5974,7 +6060,7 @@
           <a:bodyPr wrap="square" rtlCol="0" anchor="ctr"/>
           <a:lstStyle/>
           <a:p>
-            <a:pPr algn="r" indent="0" marL="0">
+            <a:pPr marL="0" indent="0" algn="r">
               <a:buNone/>
             </a:pPr>
             <a:r>
@@ -6008,6 +6094,7 @@
         <a:solidFill>
           <a:srgbClr val="FFFFFF"/>
         </a:solidFill>
+        <a:effectLst/>
       </p:bgPr>
     </p:bg>
     <p:spTree>
@@ -6045,7 +6132,7 @@
           <a:bodyPr wrap="square" rtlCol="0" anchor="ctr"/>
           <a:lstStyle/>
           <a:p>
-            <a:pPr indent="0" marL="0">
+            <a:pPr marL="0" indent="0">
               <a:buNone/>
             </a:pPr>
             <a:r>
@@ -6084,7 +6171,7 @@
           <a:bodyPr wrap="square" rtlCol="0" anchor="ctr"/>
           <a:lstStyle/>
           <a:p>
-            <a:pPr indent="0" marL="0">
+            <a:pPr marL="0" indent="0">
               <a:buNone/>
             </a:pPr>
             <a:r>
@@ -6128,13 +6215,20 @@
             <a:prstDash val="solid"/>
           </a:ln>
           <a:effectLst>
-            <a:outerShdw sx="100000" sy="100000" kx="0" ky="0" algn="bl" rotWithShape="0" blurRad="101600" dist="25400" dir="5400000">
+            <a:outerShdw blurRad="101600" dist="25400" dir="5400000" algn="bl" rotWithShape="0">
               <a:srgbClr val="B7C3BC">
                 <a:alpha val="35000"/>
               </a:srgbClr>
             </a:outerShdw>
           </a:effectLst>
         </p:spPr>
+        <p:txBody>
+          <a:bodyPr/>
+          <a:lstStyle/>
+          <a:p>
+            <a:endParaRPr lang="ko-KR" altLang="en-US"/>
+          </a:p>
+        </p:txBody>
       </p:sp>
       <p:sp>
         <p:nvSpPr>
@@ -6155,6 +6249,13 @@
           </a:solidFill>
           <a:ln/>
         </p:spPr>
+        <p:txBody>
+          <a:bodyPr/>
+          <a:lstStyle/>
+          <a:p>
+            <a:endParaRPr lang="ko-KR" altLang="en-US"/>
+          </a:p>
+        </p:txBody>
       </p:sp>
       <p:sp>
         <p:nvSpPr>
@@ -6177,7 +6278,7 @@
           <a:bodyPr wrap="square" rtlCol="0" anchor="ctr"/>
           <a:lstStyle/>
           <a:p>
-            <a:pPr algn="ctr" indent="0" marL="0">
+            <a:pPr marL="0" indent="0" algn="ctr">
               <a:buNone/>
             </a:pPr>
             <a:r>
@@ -6216,7 +6317,7 @@
           <a:bodyPr wrap="square" rtlCol="0" anchor="ctr"/>
           <a:lstStyle/>
           <a:p>
-            <a:pPr indent="0" marL="0">
+            <a:pPr marL="0" indent="0">
               <a:buNone/>
             </a:pPr>
             <a:r>
@@ -6255,7 +6356,7 @@
           <a:bodyPr wrap="square" rtlCol="0" anchor="ctr"/>
           <a:lstStyle/>
           <a:p>
-            <a:pPr indent="0" marL="0">
+            <a:pPr marL="0" indent="0">
               <a:buNone/>
             </a:pPr>
             <a:r>
@@ -6299,13 +6400,20 @@
             <a:prstDash val="solid"/>
           </a:ln>
           <a:effectLst>
-            <a:outerShdw sx="100000" sy="100000" kx="0" ky="0" algn="bl" rotWithShape="0" blurRad="101600" dist="25400" dir="5400000">
+            <a:outerShdw blurRad="101600" dist="25400" dir="5400000" algn="bl" rotWithShape="0">
               <a:srgbClr val="B7C3BC">
                 <a:alpha val="35000"/>
               </a:srgbClr>
             </a:outerShdw>
           </a:effectLst>
         </p:spPr>
+        <p:txBody>
+          <a:bodyPr/>
+          <a:lstStyle/>
+          <a:p>
+            <a:endParaRPr lang="ko-KR" altLang="en-US"/>
+          </a:p>
+        </p:txBody>
       </p:sp>
       <p:sp>
         <p:nvSpPr>
@@ -6326,6 +6434,13 @@
           </a:solidFill>
           <a:ln/>
         </p:spPr>
+        <p:txBody>
+          <a:bodyPr/>
+          <a:lstStyle/>
+          <a:p>
+            <a:endParaRPr lang="ko-KR" altLang="en-US"/>
+          </a:p>
+        </p:txBody>
       </p:sp>
       <p:sp>
         <p:nvSpPr>
@@ -6348,7 +6463,7 @@
           <a:bodyPr wrap="square" rtlCol="0" anchor="ctr"/>
           <a:lstStyle/>
           <a:p>
-            <a:pPr algn="ctr" indent="0" marL="0">
+            <a:pPr marL="0" indent="0" algn="ctr">
               <a:buNone/>
             </a:pPr>
             <a:r>
@@ -6387,7 +6502,7 @@
           <a:bodyPr wrap="square" rtlCol="0" anchor="ctr"/>
           <a:lstStyle/>
           <a:p>
-            <a:pPr indent="0" marL="0">
+            <a:pPr marL="0" indent="0">
               <a:buNone/>
             </a:pPr>
             <a:r>
@@ -6426,7 +6541,7 @@
           <a:bodyPr wrap="square" rtlCol="0" anchor="ctr"/>
           <a:lstStyle/>
           <a:p>
-            <a:pPr indent="0" marL="0">
+            <a:pPr marL="0" indent="0">
               <a:buNone/>
             </a:pPr>
             <a:r>
@@ -6470,13 +6585,20 @@
             <a:prstDash val="solid"/>
           </a:ln>
           <a:effectLst>
-            <a:outerShdw sx="100000" sy="100000" kx="0" ky="0" algn="bl" rotWithShape="0" blurRad="101600" dist="25400" dir="5400000">
+            <a:outerShdw blurRad="101600" dist="25400" dir="5400000" algn="bl" rotWithShape="0">
               <a:srgbClr val="B7C3BC">
                 <a:alpha val="35000"/>
               </a:srgbClr>
             </a:outerShdw>
           </a:effectLst>
         </p:spPr>
+        <p:txBody>
+          <a:bodyPr/>
+          <a:lstStyle/>
+          <a:p>
+            <a:endParaRPr lang="ko-KR" altLang="en-US"/>
+          </a:p>
+        </p:txBody>
       </p:sp>
       <p:sp>
         <p:nvSpPr>
@@ -6497,6 +6619,13 @@
           </a:solidFill>
           <a:ln/>
         </p:spPr>
+        <p:txBody>
+          <a:bodyPr/>
+          <a:lstStyle/>
+          <a:p>
+            <a:endParaRPr lang="ko-KR" altLang="en-US"/>
+          </a:p>
+        </p:txBody>
       </p:sp>
       <p:sp>
         <p:nvSpPr>
@@ -6519,7 +6648,7 @@
           <a:bodyPr wrap="square" rtlCol="0" anchor="ctr"/>
           <a:lstStyle/>
           <a:p>
-            <a:pPr algn="ctr" indent="0" marL="0">
+            <a:pPr marL="0" indent="0" algn="ctr">
               <a:buNone/>
             </a:pPr>
             <a:r>
@@ -6558,7 +6687,7 @@
           <a:bodyPr wrap="square" rtlCol="0" anchor="ctr"/>
           <a:lstStyle/>
           <a:p>
-            <a:pPr indent="0" marL="0">
+            <a:pPr marL="0" indent="0">
               <a:buNone/>
             </a:pPr>
             <a:r>
@@ -6597,7 +6726,7 @@
           <a:bodyPr wrap="square" rtlCol="0" anchor="ctr"/>
           <a:lstStyle/>
           <a:p>
-            <a:pPr indent="0" marL="0">
+            <a:pPr marL="0" indent="0">
               <a:buNone/>
             </a:pPr>
             <a:r>
@@ -6641,13 +6770,20 @@
             <a:prstDash val="solid"/>
           </a:ln>
           <a:effectLst>
-            <a:outerShdw sx="100000" sy="100000" kx="0" ky="0" algn="bl" rotWithShape="0" blurRad="101600" dist="25400" dir="5400000">
+            <a:outerShdw blurRad="101600" dist="25400" dir="5400000" algn="bl" rotWithShape="0">
               <a:srgbClr val="B7C3BC">
                 <a:alpha val="35000"/>
               </a:srgbClr>
             </a:outerShdw>
           </a:effectLst>
         </p:spPr>
+        <p:txBody>
+          <a:bodyPr/>
+          <a:lstStyle/>
+          <a:p>
+            <a:endParaRPr lang="ko-KR" altLang="en-US"/>
+          </a:p>
+        </p:txBody>
       </p:sp>
       <p:sp>
         <p:nvSpPr>
@@ -6668,6 +6804,13 @@
           </a:solidFill>
           <a:ln/>
         </p:spPr>
+        <p:txBody>
+          <a:bodyPr/>
+          <a:lstStyle/>
+          <a:p>
+            <a:endParaRPr lang="ko-KR" altLang="en-US"/>
+          </a:p>
+        </p:txBody>
       </p:sp>
       <p:sp>
         <p:nvSpPr>
@@ -6690,7 +6833,7 @@
           <a:bodyPr wrap="square" rtlCol="0" anchor="ctr"/>
           <a:lstStyle/>
           <a:p>
-            <a:pPr algn="ctr" indent="0" marL="0">
+            <a:pPr marL="0" indent="0" algn="ctr">
               <a:buNone/>
             </a:pPr>
             <a:r>
@@ -6729,7 +6872,7 @@
           <a:bodyPr wrap="square" rtlCol="0" anchor="ctr"/>
           <a:lstStyle/>
           <a:p>
-            <a:pPr indent="0" marL="0">
+            <a:pPr marL="0" indent="0">
               <a:buNone/>
             </a:pPr>
             <a:r>
@@ -6768,7 +6911,7 @@
           <a:bodyPr wrap="square" rtlCol="0" anchor="ctr"/>
           <a:lstStyle/>
           <a:p>
-            <a:pPr indent="0" marL="0">
+            <a:pPr marL="0" indent="0">
               <a:buNone/>
             </a:pPr>
             <a:r>
@@ -6807,7 +6950,7 @@
           <a:bodyPr wrap="square" rtlCol="0" anchor="ctr"/>
           <a:lstStyle/>
           <a:p>
-            <a:pPr algn="r" indent="0" marL="0">
+            <a:pPr marL="0" indent="0" algn="r">
               <a:buNone/>
             </a:pPr>
             <a:r>
@@ -6841,6 +6984,7 @@
         <a:solidFill>
           <a:srgbClr val="FFFFFF"/>
         </a:solidFill>
+        <a:effectLst/>
       </p:bgPr>
     </p:bg>
     <p:spTree>
@@ -6878,7 +7022,7 @@
           <a:bodyPr wrap="square" rtlCol="0" anchor="ctr"/>
           <a:lstStyle/>
           <a:p>
-            <a:pPr indent="0" marL="0">
+            <a:pPr marL="0" indent="0">
               <a:buNone/>
             </a:pPr>
             <a:r>
@@ -6917,7 +7061,7 @@
           <a:bodyPr wrap="square" rtlCol="0" anchor="ctr"/>
           <a:lstStyle/>
           <a:p>
-            <a:pPr indent="0" marL="0">
+            <a:pPr marL="0" indent="0">
               <a:buNone/>
             </a:pPr>
             <a:r>
@@ -6954,6 +7098,13 @@
           </a:solidFill>
           <a:ln/>
         </p:spPr>
+        <p:txBody>
+          <a:bodyPr/>
+          <a:lstStyle/>
+          <a:p>
+            <a:endParaRPr lang="ko-KR" altLang="en-US"/>
+          </a:p>
+        </p:txBody>
       </p:sp>
       <p:sp>
         <p:nvSpPr>
@@ -6976,7 +7127,7 @@
           <a:bodyPr wrap="square" rtlCol="0" anchor="ctr"/>
           <a:lstStyle/>
           <a:p>
-            <a:pPr algn="ctr" indent="0" marL="0">
+            <a:pPr marL="0" indent="0" algn="ctr">
               <a:buNone/>
             </a:pPr>
             <a:r>
@@ -7015,7 +7166,7 @@
           <a:bodyPr wrap="square" rtlCol="0" anchor="ctr"/>
           <a:lstStyle/>
           <a:p>
-            <a:pPr indent="0" marL="0">
+            <a:pPr marL="0" indent="0">
               <a:buNone/>
             </a:pPr>
             <a:r>
@@ -7052,6 +7203,13 @@
           </a:solidFill>
           <a:ln/>
         </p:spPr>
+        <p:txBody>
+          <a:bodyPr/>
+          <a:lstStyle/>
+          <a:p>
+            <a:endParaRPr lang="ko-KR" altLang="en-US"/>
+          </a:p>
+        </p:txBody>
       </p:sp>
       <p:sp>
         <p:nvSpPr>
@@ -7074,7 +7232,7 @@
           <a:bodyPr wrap="square" rtlCol="0" anchor="ctr"/>
           <a:lstStyle/>
           <a:p>
-            <a:pPr algn="ctr" indent="0" marL="0">
+            <a:pPr marL="0" indent="0" algn="ctr">
               <a:buNone/>
             </a:pPr>
             <a:r>
@@ -7113,7 +7271,7 @@
           <a:bodyPr wrap="square" rtlCol="0" anchor="ctr"/>
           <a:lstStyle/>
           <a:p>
-            <a:pPr indent="0" marL="0">
+            <a:pPr marL="0" indent="0">
               <a:buNone/>
             </a:pPr>
             <a:r>
@@ -7150,6 +7308,13 @@
           </a:solidFill>
           <a:ln/>
         </p:spPr>
+        <p:txBody>
+          <a:bodyPr/>
+          <a:lstStyle/>
+          <a:p>
+            <a:endParaRPr lang="ko-KR" altLang="en-US"/>
+          </a:p>
+        </p:txBody>
       </p:sp>
       <p:sp>
         <p:nvSpPr>
@@ -7172,7 +7337,7 @@
           <a:bodyPr wrap="square" rtlCol="0" anchor="ctr"/>
           <a:lstStyle/>
           <a:p>
-            <a:pPr algn="ctr" indent="0" marL="0">
+            <a:pPr marL="0" indent="0" algn="ctr">
               <a:buNone/>
             </a:pPr>
             <a:r>
@@ -7211,7 +7376,7 @@
           <a:bodyPr wrap="square" rtlCol="0" anchor="ctr"/>
           <a:lstStyle/>
           <a:p>
-            <a:pPr indent="0" marL="0">
+            <a:pPr marL="0" indent="0">
               <a:buNone/>
             </a:pPr>
             <a:r>
@@ -7248,6 +7413,13 @@
           </a:solidFill>
           <a:ln/>
         </p:spPr>
+        <p:txBody>
+          <a:bodyPr/>
+          <a:lstStyle/>
+          <a:p>
+            <a:endParaRPr lang="ko-KR" altLang="en-US"/>
+          </a:p>
+        </p:txBody>
       </p:sp>
       <p:sp>
         <p:nvSpPr>
@@ -7270,7 +7442,7 @@
           <a:bodyPr wrap="square" rtlCol="0" anchor="ctr"/>
           <a:lstStyle/>
           <a:p>
-            <a:pPr algn="ctr" indent="0" marL="0">
+            <a:pPr marL="0" indent="0" algn="ctr">
               <a:buNone/>
             </a:pPr>
             <a:r>
@@ -7309,7 +7481,7 @@
           <a:bodyPr wrap="square" rtlCol="0" anchor="ctr"/>
           <a:lstStyle/>
           <a:p>
-            <a:pPr indent="0" marL="0">
+            <a:pPr marL="0" indent="0">
               <a:buNone/>
             </a:pPr>
             <a:r>
@@ -7346,6 +7518,13 @@
           </a:solidFill>
           <a:ln/>
         </p:spPr>
+        <p:txBody>
+          <a:bodyPr/>
+          <a:lstStyle/>
+          <a:p>
+            <a:endParaRPr lang="ko-KR" altLang="en-US"/>
+          </a:p>
+        </p:txBody>
       </p:sp>
       <p:sp>
         <p:nvSpPr>
@@ -7368,7 +7547,7 @@
           <a:bodyPr wrap="square" rtlCol="0" anchor="ctr"/>
           <a:lstStyle/>
           <a:p>
-            <a:pPr algn="ctr" indent="0" marL="0">
+            <a:pPr marL="0" indent="0" algn="ctr">
               <a:buNone/>
             </a:pPr>
             <a:r>
@@ -7407,7 +7586,7 @@
           <a:bodyPr wrap="square" rtlCol="0" anchor="ctr"/>
           <a:lstStyle/>
           <a:p>
-            <a:pPr indent="0" marL="0">
+            <a:pPr marL="0" indent="0">
               <a:buNone/>
             </a:pPr>
             <a:r>
@@ -7444,6 +7623,13 @@
           </a:solidFill>
           <a:ln/>
         </p:spPr>
+        <p:txBody>
+          <a:bodyPr/>
+          <a:lstStyle/>
+          <a:p>
+            <a:endParaRPr lang="ko-KR" altLang="en-US"/>
+          </a:p>
+        </p:txBody>
       </p:sp>
       <p:sp>
         <p:nvSpPr>
@@ -7466,7 +7652,7 @@
           <a:bodyPr wrap="square" rtlCol="0" anchor="ctr"/>
           <a:lstStyle/>
           <a:p>
-            <a:pPr algn="ctr" indent="0" marL="0">
+            <a:pPr marL="0" indent="0" algn="ctr">
               <a:buNone/>
             </a:pPr>
             <a:r>
@@ -7505,7 +7691,7 @@
           <a:bodyPr wrap="square" rtlCol="0" anchor="ctr"/>
           <a:lstStyle/>
           <a:p>
-            <a:pPr indent="0" marL="0">
+            <a:pPr marL="0" indent="0">
               <a:buNone/>
             </a:pPr>
             <a:r>
@@ -7542,6 +7728,13 @@
           </a:solidFill>
           <a:ln/>
         </p:spPr>
+        <p:txBody>
+          <a:bodyPr/>
+          <a:lstStyle/>
+          <a:p>
+            <a:endParaRPr lang="ko-KR" altLang="en-US"/>
+          </a:p>
+        </p:txBody>
       </p:sp>
       <p:sp>
         <p:nvSpPr>
@@ -7564,7 +7757,7 @@
           <a:bodyPr wrap="square" rtlCol="0" anchor="ctr"/>
           <a:lstStyle/>
           <a:p>
-            <a:pPr algn="ctr" indent="0" marL="0">
+            <a:pPr marL="0" indent="0" algn="ctr">
               <a:buNone/>
             </a:pPr>
             <a:r>
@@ -7603,7 +7796,7 @@
           <a:bodyPr wrap="square" rtlCol="0" anchor="ctr"/>
           <a:lstStyle/>
           <a:p>
-            <a:pPr indent="0" marL="0">
+            <a:pPr marL="0" indent="0">
               <a:buNone/>
             </a:pPr>
             <a:r>
@@ -7640,6 +7833,13 @@
           </a:solidFill>
           <a:ln/>
         </p:spPr>
+        <p:txBody>
+          <a:bodyPr/>
+          <a:lstStyle/>
+          <a:p>
+            <a:endParaRPr lang="ko-KR" altLang="en-US"/>
+          </a:p>
+        </p:txBody>
       </p:sp>
       <p:sp>
         <p:nvSpPr>
@@ -7662,7 +7862,7 @@
           <a:bodyPr wrap="square" rtlCol="0" anchor="ctr"/>
           <a:lstStyle/>
           <a:p>
-            <a:pPr algn="ctr" indent="0" marL="0">
+            <a:pPr marL="0" indent="0" algn="ctr">
               <a:buNone/>
             </a:pPr>
             <a:r>
@@ -7701,7 +7901,7 @@
           <a:bodyPr wrap="square" rtlCol="0" anchor="ctr"/>
           <a:lstStyle/>
           <a:p>
-            <a:pPr indent="0" marL="0">
+            <a:pPr marL="0" indent="0">
               <a:buNone/>
             </a:pPr>
             <a:r>
@@ -7713,7 +7913,29 @@
                 <a:ea typeface="Calibri" pitchFamily="34" charset="-122"/>
                 <a:cs typeface="Calibri" pitchFamily="34" charset="-120"/>
               </a:rPr>
-              <a:t>3 til: o'zbek / rus / ingliz</a:t>
+              <a:t>2 til: o'zbek / </a:t>
+            </a:r>
+            <a:r>
+              <a:rPr lang="en-US" sz="1350" dirty="0" err="1">
+                <a:solidFill>
+                  <a:srgbClr val="374151"/>
+                </a:solidFill>
+                <a:latin typeface="Calibri" pitchFamily="34" charset="0"/>
+                <a:ea typeface="Calibri" pitchFamily="34" charset="-122"/>
+                <a:cs typeface="Calibri" pitchFamily="34" charset="-120"/>
+              </a:rPr>
+              <a:t>rus</a:t>
+            </a:r>
+            <a:r>
+              <a:rPr lang="en-US" sz="1350" dirty="0">
+                <a:solidFill>
+                  <a:srgbClr val="374151"/>
+                </a:solidFill>
+                <a:latin typeface="Calibri" pitchFamily="34" charset="0"/>
+                <a:ea typeface="Calibri" pitchFamily="34" charset="-122"/>
+                <a:cs typeface="Calibri" pitchFamily="34" charset="-120"/>
+              </a:rPr>
+              <a:t> </a:t>
             </a:r>
             <a:endParaRPr lang="en-US" sz="1350" dirty="0"/>
           </a:p>
@@ -7745,13 +7967,20 @@
             <a:prstDash val="solid"/>
           </a:ln>
           <a:effectLst>
-            <a:outerShdw sx="100000" sy="100000" kx="0" ky="0" algn="bl" rotWithShape="0" blurRad="101600" dist="25400" dir="5400000">
+            <a:outerShdw blurRad="101600" dist="25400" dir="5400000" algn="bl" rotWithShape="0">
               <a:srgbClr val="B7C3BC">
                 <a:alpha val="35000"/>
               </a:srgbClr>
             </a:outerShdw>
           </a:effectLst>
         </p:spPr>
+        <p:txBody>
+          <a:bodyPr/>
+          <a:lstStyle/>
+          <a:p>
+            <a:endParaRPr lang="ko-KR" altLang="en-US"/>
+          </a:p>
+        </p:txBody>
       </p:sp>
       <p:sp>
         <p:nvSpPr>
@@ -7774,7 +8003,7 @@
           <a:bodyPr wrap="square" rtlCol="0" anchor="ctr"/>
           <a:lstStyle/>
           <a:p>
-            <a:pPr indent="0" marL="0">
+            <a:pPr marL="0" indent="0">
               <a:buNone/>
             </a:pPr>
             <a:r>
@@ -7788,9 +8017,6 @@
               </a:rPr>
               <a:t>Google Play Store'da jonli</a:t>
             </a:r>
-            <a:pPr indent="0" marL="0">
-              <a:buNone/>
-            </a:pPr>
             <a:r>
               <a:rPr lang="en-US" sz="1500" dirty="0">
                 <a:solidFill>
@@ -7827,7 +8053,7 @@
           <a:bodyPr wrap="square" rtlCol="0" anchor="ctr"/>
           <a:lstStyle/>
           <a:p>
-            <a:pPr algn="r" indent="0" marL="0">
+            <a:pPr marL="0" indent="0" algn="r">
               <a:buNone/>
             </a:pPr>
             <a:r>
@@ -7861,6 +8087,7 @@
         <a:solidFill>
           <a:srgbClr val="FFFFFF"/>
         </a:solidFill>
+        <a:effectLst/>
       </p:bgPr>
     </p:bg>
     <p:spTree>
@@ -7898,7 +8125,7 @@
           <a:bodyPr wrap="square" rtlCol="0" anchor="ctr"/>
           <a:lstStyle/>
           <a:p>
-            <a:pPr indent="0" marL="0">
+            <a:pPr marL="0" indent="0">
               <a:buNone/>
             </a:pPr>
             <a:r>
@@ -7937,7 +8164,7 @@
           <a:bodyPr wrap="square" rtlCol="0" anchor="ctr"/>
           <a:lstStyle/>
           <a:p>
-            <a:pPr indent="0" marL="0">
+            <a:pPr marL="0" indent="0">
               <a:buNone/>
             </a:pPr>
             <a:r>
@@ -7974,6 +8201,13 @@
           </a:solidFill>
           <a:ln/>
         </p:spPr>
+        <p:txBody>
+          <a:bodyPr/>
+          <a:lstStyle/>
+          <a:p>
+            <a:endParaRPr lang="ko-KR" altLang="en-US"/>
+          </a:p>
+        </p:txBody>
       </p:sp>
       <p:sp>
         <p:nvSpPr>
@@ -7996,7 +8230,7 @@
           <a:bodyPr wrap="square" rtlCol="0" anchor="t"/>
           <a:lstStyle/>
           <a:p>
-            <a:pPr indent="0" marL="0">
+            <a:pPr marL="0" indent="0">
               <a:buNone/>
             </a:pPr>
             <a:r>
@@ -8010,9 +8244,6 @@
               </a:rPr>
               <a:t>646-son qaror (2018) — </a:t>
             </a:r>
-            <a:pPr indent="0" marL="0">
-              <a:buNone/>
-            </a:pPr>
             <a:r>
               <a:rPr lang="en-US" sz="1350" dirty="0">
                 <a:solidFill>
@@ -8047,6 +8278,13 @@
           </a:solidFill>
           <a:ln/>
         </p:spPr>
+        <p:txBody>
+          <a:bodyPr/>
+          <a:lstStyle/>
+          <a:p>
+            <a:endParaRPr lang="ko-KR" altLang="en-US"/>
+          </a:p>
+        </p:txBody>
       </p:sp>
       <p:sp>
         <p:nvSpPr>
@@ -8069,7 +8307,7 @@
           <a:bodyPr wrap="square" rtlCol="0" anchor="t"/>
           <a:lstStyle/>
           <a:p>
-            <a:pPr indent="0" marL="0">
+            <a:pPr marL="0" indent="0">
               <a:buNone/>
             </a:pPr>
             <a:r>
@@ -8083,9 +8321,6 @@
               </a:rPr>
               <a:t>Bo'shliq — </a:t>
             </a:r>
-            <a:pPr indent="0" marL="0">
-              <a:buNone/>
-            </a:pPr>
             <a:r>
               <a:rPr lang="en-US" sz="1350" dirty="0">
                 <a:solidFill>
@@ -8120,6 +8355,13 @@
           </a:solidFill>
           <a:ln/>
         </p:spPr>
+        <p:txBody>
+          <a:bodyPr/>
+          <a:lstStyle/>
+          <a:p>
+            <a:endParaRPr lang="ko-KR" altLang="en-US"/>
+          </a:p>
+        </p:txBody>
       </p:sp>
       <p:sp>
         <p:nvSpPr>
@@ -8142,7 +8384,7 @@
           <a:bodyPr wrap="square" rtlCol="0" anchor="t"/>
           <a:lstStyle/>
           <a:p>
-            <a:pPr indent="0" marL="0">
+            <a:pPr marL="0" indent="0">
               <a:buNone/>
             </a:pPr>
             <a:r>
@@ -8156,9 +8398,6 @@
               </a:rPr>
               <a:t>Yechim — </a:t>
             </a:r>
-            <a:pPr indent="0" marL="0">
-              <a:buNone/>
-            </a:pPr>
             <a:r>
               <a:rPr lang="en-US" sz="1350" dirty="0">
                 <a:solidFill>
@@ -8193,6 +8432,13 @@
           </a:solidFill>
           <a:ln/>
         </p:spPr>
+        <p:txBody>
+          <a:bodyPr/>
+          <a:lstStyle/>
+          <a:p>
+            <a:endParaRPr lang="ko-KR" altLang="en-US"/>
+          </a:p>
+        </p:txBody>
       </p:sp>
       <p:sp>
         <p:nvSpPr>
@@ -8215,7 +8461,7 @@
           <a:bodyPr wrap="square" rtlCol="0" anchor="t"/>
           <a:lstStyle/>
           <a:p>
-            <a:pPr indent="0" marL="0">
+            <a:pPr marL="0" indent="0">
               <a:buNone/>
             </a:pPr>
             <a:r>
@@ -8229,9 +8475,6 @@
               </a:rPr>
               <a:t>Rais — </a:t>
             </a:r>
-            <a:pPr indent="0" marL="0">
-              <a:buNone/>
-            </a:pPr>
             <a:r>
               <a:rPr lang="en-US" sz="1350" dirty="0">
                 <a:solidFill>
@@ -8273,6 +8516,13 @@
             <a:prstDash val="solid"/>
           </a:ln>
         </p:spPr>
+        <p:txBody>
+          <a:bodyPr/>
+          <a:lstStyle/>
+          <a:p>
+            <a:endParaRPr lang="ko-KR" altLang="en-US"/>
+          </a:p>
+        </p:txBody>
       </p:sp>
       <p:sp>
         <p:nvSpPr>
@@ -8295,6 +8545,13 @@
           </a:solidFill>
           <a:ln/>
         </p:spPr>
+        <p:txBody>
+          <a:bodyPr/>
+          <a:lstStyle/>
+          <a:p>
+            <a:endParaRPr lang="ko-KR" altLang="en-US"/>
+          </a:p>
+        </p:txBody>
       </p:sp>
       <p:sp>
         <p:nvSpPr>
@@ -8317,7 +8574,7 @@
           <a:bodyPr wrap="square" rtlCol="0" anchor="ctr"/>
           <a:lstStyle/>
           <a:p>
-            <a:pPr algn="ctr" indent="0" marL="0">
+            <a:pPr marL="0" indent="0" algn="ctr">
               <a:buNone/>
             </a:pPr>
             <a:r>
@@ -8356,7 +8613,7 @@
           <a:bodyPr wrap="square" rtlCol="0" anchor="ctr"/>
           <a:lstStyle/>
           <a:p>
-            <a:pPr algn="ctr" indent="0" marL="0">
+            <a:pPr marL="0" indent="0" algn="ctr">
               <a:buNone/>
             </a:pPr>
             <a:r>
@@ -8395,6 +8652,13 @@
           </a:solidFill>
           <a:ln/>
         </p:spPr>
+        <p:txBody>
+          <a:bodyPr/>
+          <a:lstStyle/>
+          <a:p>
+            <a:endParaRPr lang="ko-KR" altLang="en-US"/>
+          </a:p>
+        </p:txBody>
       </p:sp>
       <p:sp>
         <p:nvSpPr>
@@ -8417,7 +8681,7 @@
           <a:bodyPr wrap="square" rtlCol="0" anchor="ctr"/>
           <a:lstStyle/>
           <a:p>
-            <a:pPr indent="0" marL="0">
+            <a:pPr marL="0" indent="0">
               <a:buNone/>
             </a:pPr>
             <a:r>
@@ -8456,7 +8720,7 @@
           <a:bodyPr wrap="square" rtlCol="0" anchor="ctr"/>
           <a:lstStyle/>
           <a:p>
-            <a:pPr algn="r" indent="0" marL="0">
+            <a:pPr marL="0" indent="0" algn="r">
               <a:buNone/>
             </a:pPr>
             <a:r>
@@ -8495,6 +8759,13 @@
           </a:solidFill>
           <a:ln/>
         </p:spPr>
+        <p:txBody>
+          <a:bodyPr/>
+          <a:lstStyle/>
+          <a:p>
+            <a:endParaRPr lang="ko-KR" altLang="en-US"/>
+          </a:p>
+        </p:txBody>
       </p:sp>
       <p:sp>
         <p:nvSpPr>
@@ -8517,7 +8788,7 @@
           <a:bodyPr wrap="square" rtlCol="0" anchor="ctr"/>
           <a:lstStyle/>
           <a:p>
-            <a:pPr indent="0" marL="0">
+            <a:pPr marL="0" indent="0">
               <a:buNone/>
             </a:pPr>
             <a:r>
@@ -8556,7 +8827,7 @@
           <a:bodyPr wrap="square" rtlCol="0" anchor="ctr"/>
           <a:lstStyle/>
           <a:p>
-            <a:pPr algn="r" indent="0" marL="0">
+            <a:pPr marL="0" indent="0" algn="r">
               <a:buNone/>
             </a:pPr>
             <a:r>
@@ -8595,6 +8866,13 @@
           </a:solidFill>
           <a:ln/>
         </p:spPr>
+        <p:txBody>
+          <a:bodyPr/>
+          <a:lstStyle/>
+          <a:p>
+            <a:endParaRPr lang="ko-KR" altLang="en-US"/>
+          </a:p>
+        </p:txBody>
       </p:sp>
       <p:sp>
         <p:nvSpPr>
@@ -8617,7 +8895,7 @@
           <a:bodyPr wrap="square" rtlCol="0" anchor="ctr"/>
           <a:lstStyle/>
           <a:p>
-            <a:pPr indent="0" marL="0">
+            <a:pPr marL="0" indent="0">
               <a:buNone/>
             </a:pPr>
             <a:r>
@@ -8656,7 +8934,7 @@
           <a:bodyPr wrap="square" rtlCol="0" anchor="ctr"/>
           <a:lstStyle/>
           <a:p>
-            <a:pPr algn="r" indent="0" marL="0">
+            <a:pPr marL="0" indent="0" algn="r">
               <a:buNone/>
             </a:pPr>
             <a:r>
@@ -8695,6 +8973,13 @@
           </a:solidFill>
           <a:ln/>
         </p:spPr>
+        <p:txBody>
+          <a:bodyPr/>
+          <a:lstStyle/>
+          <a:p>
+            <a:endParaRPr lang="ko-KR" altLang="en-US"/>
+          </a:p>
+        </p:txBody>
       </p:sp>
       <p:sp>
         <p:nvSpPr>
@@ -8717,7 +9002,7 @@
           <a:bodyPr wrap="square" rtlCol="0" anchor="ctr"/>
           <a:lstStyle/>
           <a:p>
-            <a:pPr indent="0" marL="0">
+            <a:pPr marL="0" indent="0">
               <a:buNone/>
             </a:pPr>
             <a:r>
@@ -8756,7 +9041,7 @@
           <a:bodyPr wrap="square" rtlCol="0" anchor="ctr"/>
           <a:lstStyle/>
           <a:p>
-            <a:pPr algn="r" indent="0" marL="0">
+            <a:pPr marL="0" indent="0" algn="r">
               <a:buNone/>
             </a:pPr>
             <a:r>
@@ -8795,7 +9080,7 @@
           <a:bodyPr wrap="square" rtlCol="0" anchor="ctr"/>
           <a:lstStyle/>
           <a:p>
-            <a:pPr algn="r" indent="0" marL="0">
+            <a:pPr marL="0" indent="0" algn="r">
               <a:buNone/>
             </a:pPr>
             <a:r>
@@ -8829,6 +9114,7 @@
         <a:solidFill>
           <a:srgbClr val="FFFFFF"/>
         </a:solidFill>
+        <a:effectLst/>
       </p:bgPr>
     </p:bg>
     <p:spTree>
@@ -8866,7 +9152,7 @@
           <a:bodyPr wrap="square" rtlCol="0" anchor="ctr"/>
           <a:lstStyle/>
           <a:p>
-            <a:pPr indent="0" marL="0">
+            <a:pPr marL="0" indent="0">
               <a:buNone/>
             </a:pPr>
             <a:r>
@@ -8905,7 +9191,7 @@
           <a:bodyPr wrap="square" rtlCol="0" anchor="ctr"/>
           <a:lstStyle/>
           <a:p>
-            <a:pPr indent="0" marL="0">
+            <a:pPr marL="0" indent="0">
               <a:buNone/>
             </a:pPr>
             <a:r>
@@ -8949,13 +9235,20 @@
             <a:prstDash val="solid"/>
           </a:ln>
           <a:effectLst>
-            <a:outerShdw sx="100000" sy="100000" kx="0" ky="0" algn="bl" rotWithShape="0" blurRad="101600" dist="25400" dir="5400000">
+            <a:outerShdw blurRad="101600" dist="25400" dir="5400000" algn="bl" rotWithShape="0">
               <a:srgbClr val="B7C3BC">
                 <a:alpha val="35000"/>
               </a:srgbClr>
             </a:outerShdw>
           </a:effectLst>
         </p:spPr>
+        <p:txBody>
+          <a:bodyPr/>
+          <a:lstStyle/>
+          <a:p>
+            <a:endParaRPr lang="ko-KR" altLang="en-US"/>
+          </a:p>
+        </p:txBody>
       </p:sp>
       <p:sp>
         <p:nvSpPr>
@@ -8976,6 +9269,13 @@
           </a:solidFill>
           <a:ln/>
         </p:spPr>
+        <p:txBody>
+          <a:bodyPr/>
+          <a:lstStyle/>
+          <a:p>
+            <a:endParaRPr lang="ko-KR" altLang="en-US"/>
+          </a:p>
+        </p:txBody>
       </p:sp>
       <p:sp>
         <p:nvSpPr>
@@ -8998,7 +9298,7 @@
           <a:bodyPr wrap="square" rtlCol="0" anchor="ctr"/>
           <a:lstStyle/>
           <a:p>
-            <a:pPr algn="ctr" indent="0" marL="0">
+            <a:pPr marL="0" indent="0" algn="ctr">
               <a:buNone/>
             </a:pPr>
             <a:r>
@@ -9037,7 +9337,7 @@
           <a:bodyPr wrap="square" rtlCol="0" anchor="ctr"/>
           <a:lstStyle/>
           <a:p>
-            <a:pPr algn="ctr" indent="0" marL="0">
+            <a:pPr marL="0" indent="0" algn="ctr">
               <a:buNone/>
             </a:pPr>
             <a:r>
@@ -9076,7 +9376,7 @@
           <a:bodyPr wrap="square" rtlCol="0" anchor="ctr"/>
           <a:lstStyle/>
           <a:p>
-            <a:pPr algn="ctr" indent="0" marL="0">
+            <a:pPr marL="0" indent="0" algn="ctr">
               <a:buNone/>
             </a:pPr>
             <a:r>
@@ -9120,13 +9420,20 @@
             <a:prstDash val="solid"/>
           </a:ln>
           <a:effectLst>
-            <a:outerShdw sx="100000" sy="100000" kx="0" ky="0" algn="bl" rotWithShape="0" blurRad="101600" dist="25400" dir="5400000">
+            <a:outerShdw blurRad="101600" dist="25400" dir="5400000" algn="bl" rotWithShape="0">
               <a:srgbClr val="B7C3BC">
                 <a:alpha val="35000"/>
               </a:srgbClr>
             </a:outerShdw>
           </a:effectLst>
         </p:spPr>
+        <p:txBody>
+          <a:bodyPr/>
+          <a:lstStyle/>
+          <a:p>
+            <a:endParaRPr lang="ko-KR" altLang="en-US"/>
+          </a:p>
+        </p:txBody>
       </p:sp>
       <p:sp>
         <p:nvSpPr>
@@ -9147,6 +9454,13 @@
           </a:solidFill>
           <a:ln/>
         </p:spPr>
+        <p:txBody>
+          <a:bodyPr/>
+          <a:lstStyle/>
+          <a:p>
+            <a:endParaRPr lang="ko-KR" altLang="en-US"/>
+          </a:p>
+        </p:txBody>
       </p:sp>
       <p:sp>
         <p:nvSpPr>
@@ -9169,7 +9483,7 @@
           <a:bodyPr wrap="square" rtlCol="0" anchor="ctr"/>
           <a:lstStyle/>
           <a:p>
-            <a:pPr algn="ctr" indent="0" marL="0">
+            <a:pPr marL="0" indent="0" algn="ctr">
               <a:buNone/>
             </a:pPr>
             <a:r>
@@ -9208,7 +9522,7 @@
           <a:bodyPr wrap="square" rtlCol="0" anchor="ctr"/>
           <a:lstStyle/>
           <a:p>
-            <a:pPr algn="ctr" indent="0" marL="0">
+            <a:pPr marL="0" indent="0" algn="ctr">
               <a:buNone/>
             </a:pPr>
             <a:r>
@@ -9247,7 +9561,7 @@
           <a:bodyPr wrap="square" rtlCol="0" anchor="ctr"/>
           <a:lstStyle/>
           <a:p>
-            <a:pPr algn="ctr" indent="0" marL="0">
+            <a:pPr marL="0" indent="0" algn="ctr">
               <a:buNone/>
             </a:pPr>
             <a:r>
@@ -9291,13 +9605,20 @@
             <a:prstDash val="solid"/>
           </a:ln>
           <a:effectLst>
-            <a:outerShdw sx="100000" sy="100000" kx="0" ky="0" algn="bl" rotWithShape="0" blurRad="101600" dist="25400" dir="5400000">
+            <a:outerShdw blurRad="101600" dist="25400" dir="5400000" algn="bl" rotWithShape="0">
               <a:srgbClr val="B7C3BC">
                 <a:alpha val="35000"/>
               </a:srgbClr>
             </a:outerShdw>
           </a:effectLst>
         </p:spPr>
+        <p:txBody>
+          <a:bodyPr/>
+          <a:lstStyle/>
+          <a:p>
+            <a:endParaRPr lang="ko-KR" altLang="en-US"/>
+          </a:p>
+        </p:txBody>
       </p:sp>
       <p:sp>
         <p:nvSpPr>
@@ -9318,6 +9639,13 @@
           </a:solidFill>
           <a:ln/>
         </p:spPr>
+        <p:txBody>
+          <a:bodyPr/>
+          <a:lstStyle/>
+          <a:p>
+            <a:endParaRPr lang="ko-KR" altLang="en-US"/>
+          </a:p>
+        </p:txBody>
       </p:sp>
       <p:sp>
         <p:nvSpPr>
@@ -9340,7 +9668,7 @@
           <a:bodyPr wrap="square" rtlCol="0" anchor="ctr"/>
           <a:lstStyle/>
           <a:p>
-            <a:pPr algn="ctr" indent="0" marL="0">
+            <a:pPr marL="0" indent="0" algn="ctr">
               <a:buNone/>
             </a:pPr>
             <a:r>
@@ -9379,7 +9707,7 @@
           <a:bodyPr wrap="square" rtlCol="0" anchor="ctr"/>
           <a:lstStyle/>
           <a:p>
-            <a:pPr algn="ctr" indent="0" marL="0">
+            <a:pPr marL="0" indent="0" algn="ctr">
               <a:buNone/>
             </a:pPr>
             <a:r>
@@ -9418,7 +9746,7 @@
           <a:bodyPr wrap="square" rtlCol="0" anchor="ctr"/>
           <a:lstStyle/>
           <a:p>
-            <a:pPr algn="ctr" indent="0" marL="0">
+            <a:pPr marL="0" indent="0" algn="ctr">
               <a:buNone/>
             </a:pPr>
             <a:r>
@@ -9457,7 +9785,7 @@
           <a:bodyPr wrap="square" rtlCol="0" anchor="ctr"/>
           <a:lstStyle/>
           <a:p>
-            <a:pPr algn="ctr" indent="0" marL="0">
+            <a:pPr marL="0" indent="0" algn="ctr">
               <a:buNone/>
             </a:pPr>
             <a:r>
@@ -9496,7 +9824,7 @@
           <a:bodyPr wrap="square" rtlCol="0" anchor="ctr"/>
           <a:lstStyle/>
           <a:p>
-            <a:pPr algn="r" indent="0" marL="0">
+            <a:pPr marL="0" indent="0" algn="r">
               <a:buNone/>
             </a:pPr>
             <a:r>
@@ -9530,6 +9858,7 @@
         <a:solidFill>
           <a:srgbClr val="FFFFFF"/>
         </a:solidFill>
+        <a:effectLst/>
       </p:bgPr>
     </p:bg>
     <p:spTree>
@@ -9567,7 +9896,7 @@
           <a:bodyPr wrap="square" rtlCol="0" anchor="ctr"/>
           <a:lstStyle/>
           <a:p>
-            <a:pPr indent="0" marL="0">
+            <a:pPr marL="0" indent="0">
               <a:buNone/>
             </a:pPr>
             <a:r>
@@ -9606,7 +9935,7 @@
           <a:bodyPr wrap="square" rtlCol="0" anchor="ctr"/>
           <a:lstStyle/>
           <a:p>
-            <a:pPr indent="0" marL="0">
+            <a:pPr marL="0" indent="0">
               <a:buNone/>
             </a:pPr>
             <a:r>
@@ -9645,6 +9974,13 @@
           </a:solidFill>
           <a:ln/>
         </p:spPr>
+        <p:txBody>
+          <a:bodyPr/>
+          <a:lstStyle/>
+          <a:p>
+            <a:endParaRPr lang="ko-KR" altLang="en-US"/>
+          </a:p>
+        </p:txBody>
       </p:sp>
       <p:sp>
         <p:nvSpPr>
@@ -9667,6 +10003,13 @@
           </a:solidFill>
           <a:ln/>
         </p:spPr>
+        <p:txBody>
+          <a:bodyPr/>
+          <a:lstStyle/>
+          <a:p>
+            <a:endParaRPr lang="ko-KR" altLang="en-US"/>
+          </a:p>
+        </p:txBody>
       </p:sp>
       <p:sp>
         <p:nvSpPr>
@@ -9689,7 +10032,7 @@
           <a:bodyPr wrap="square" rtlCol="0" anchor="ctr"/>
           <a:lstStyle/>
           <a:p>
-            <a:pPr algn="ctr" indent="0" marL="0">
+            <a:pPr marL="0" indent="0" algn="ctr">
               <a:buNone/>
             </a:pPr>
             <a:r>
@@ -9728,6 +10071,13 @@
           </a:solidFill>
           <a:ln/>
         </p:spPr>
+        <p:txBody>
+          <a:bodyPr/>
+          <a:lstStyle/>
+          <a:p>
+            <a:endParaRPr lang="ko-KR" altLang="en-US"/>
+          </a:p>
+        </p:txBody>
       </p:sp>
       <p:sp>
         <p:nvSpPr>
@@ -9750,11 +10100,11 @@
           <a:bodyPr wrap="square" rtlCol="0" anchor="ctr"/>
           <a:lstStyle/>
           <a:p>
-            <a:pPr algn="ctr" indent="0" marL="0">
-              <a:buNone/>
-            </a:pPr>
-            <a:r>
-              <a:rPr lang="en-US" sz="1400" b="1" dirty="0">
+            <a:pPr marL="0" indent="0" algn="ctr">
+              <a:buNone/>
+            </a:pPr>
+            <a:r>
+              <a:rPr lang="en-US" sz="1400" b="1" dirty="0" err="1">
                 <a:solidFill>
                   <a:srgbClr val="0F1E16"/>
                 </a:solidFill>
@@ -9762,7 +10112,7 @@
                 <a:ea typeface="Calibri" pitchFamily="34" charset="-122"/>
                 <a:cs typeface="Calibri" pitchFamily="34" charset="-120"/>
               </a:rPr>
-              <a:t>Mango</a:t>
+              <a:t>Olx</a:t>
             </a:r>
             <a:endParaRPr lang="en-US" sz="1400" dirty="0"/>
           </a:p>
@@ -9789,6 +10139,13 @@
           </a:solidFill>
           <a:ln/>
         </p:spPr>
+        <p:txBody>
+          <a:bodyPr/>
+          <a:lstStyle/>
+          <a:p>
+            <a:endParaRPr lang="ko-KR" altLang="en-US"/>
+          </a:p>
+        </p:txBody>
       </p:sp>
       <p:sp>
         <p:nvSpPr>
@@ -9811,7 +10168,7 @@
           <a:bodyPr wrap="square" rtlCol="0" anchor="ctr"/>
           <a:lstStyle/>
           <a:p>
-            <a:pPr algn="ctr" indent="0" marL="0">
+            <a:pPr marL="0" indent="0" algn="ctr">
               <a:buNone/>
             </a:pPr>
             <a:r>
@@ -9850,7 +10207,7 @@
           <a:bodyPr wrap="square" rtlCol="0" anchor="ctr"/>
           <a:lstStyle/>
           <a:p>
-            <a:pPr algn="l" indent="0" marL="0">
+            <a:pPr marL="0" indent="0" algn="l">
               <a:buNone/>
             </a:pPr>
             <a:r>
@@ -9889,7 +10246,7 @@
           <a:bodyPr wrap="square" rtlCol="0" anchor="ctr"/>
           <a:lstStyle/>
           <a:p>
-            <a:pPr algn="ctr" indent="0" marL="0">
+            <a:pPr marL="0" indent="0" algn="ctr">
               <a:buNone/>
             </a:pPr>
             <a:r>
@@ -9928,11 +10285,9 @@
           <a:bodyPr wrap="square" rtlCol="0" anchor="ctr"/>
           <a:lstStyle/>
           <a:p>
-            <a:pPr algn="ctr" indent="0" marL="0">
-              <a:buNone/>
-            </a:pPr>
-            <a:r>
-              <a:rPr lang="en-US" sz="1300" dirty="0">
+            <a:pPr algn="ctr"/>
+            <a:r>
+              <a:rPr lang="en-US" altLang="ko-KR" sz="1300" dirty="0" err="1">
                 <a:solidFill>
                   <a:srgbClr val="374151"/>
                 </a:solidFill>
@@ -9940,9 +10295,31 @@
                 <a:ea typeface="Calibri" pitchFamily="34" charset="-122"/>
                 <a:cs typeface="Calibri" pitchFamily="34" charset="-120"/>
               </a:rPr>
-              <a:t>Carrot klon</a:t>
-            </a:r>
-            <a:endParaRPr lang="en-US" sz="1300" dirty="0"/>
+              <a:t>Milliy</a:t>
+            </a:r>
+            <a:r>
+              <a:rPr lang="en-US" altLang="ko-KR" sz="1300" dirty="0">
+                <a:solidFill>
+                  <a:srgbClr val="374151"/>
+                </a:solidFill>
+                <a:latin typeface="Calibri" pitchFamily="34" charset="0"/>
+                <a:ea typeface="Calibri" pitchFamily="34" charset="-122"/>
+                <a:cs typeface="Calibri" pitchFamily="34" charset="-120"/>
+              </a:rPr>
+              <a:t> </a:t>
+            </a:r>
+            <a:r>
+              <a:rPr lang="en-US" altLang="ko-KR" sz="1300" dirty="0" err="1">
+                <a:solidFill>
+                  <a:srgbClr val="374151"/>
+                </a:solidFill>
+                <a:latin typeface="Calibri" pitchFamily="34" charset="0"/>
+                <a:ea typeface="Calibri" pitchFamily="34" charset="-122"/>
+                <a:cs typeface="Calibri" pitchFamily="34" charset="-120"/>
+              </a:rPr>
+              <a:t>klassifayd</a:t>
+            </a:r>
+            <a:endParaRPr lang="en-US" altLang="ko-KR" sz="1300" dirty="0"/>
           </a:p>
         </p:txBody>
       </p:sp>
@@ -9965,6 +10342,13 @@
           </a:solidFill>
           <a:ln/>
         </p:spPr>
+        <p:txBody>
+          <a:bodyPr/>
+          <a:lstStyle/>
+          <a:p>
+            <a:endParaRPr lang="ko-KR" altLang="en-US"/>
+          </a:p>
+        </p:txBody>
       </p:sp>
       <p:sp>
         <p:nvSpPr>
@@ -9987,7 +10371,7 @@
           <a:bodyPr wrap="square" rtlCol="0" anchor="ctr"/>
           <a:lstStyle/>
           <a:p>
-            <a:pPr algn="ctr" indent="0" marL="0">
+            <a:pPr marL="0" indent="0" algn="ctr">
               <a:buNone/>
             </a:pPr>
             <a:r>
@@ -10027,6 +10411,13 @@
             <a:prstDash val="solid"/>
           </a:ln>
         </p:spPr>
+        <p:txBody>
+          <a:bodyPr/>
+          <a:lstStyle/>
+          <a:p>
+            <a:endParaRPr lang="ko-KR" altLang="en-US"/>
+          </a:p>
+        </p:txBody>
       </p:sp>
       <p:sp>
         <p:nvSpPr>
@@ -10049,7 +10440,7 @@
           <a:bodyPr wrap="square" rtlCol="0" anchor="ctr"/>
           <a:lstStyle/>
           <a:p>
-            <a:pPr algn="l" indent="0" marL="0">
+            <a:pPr marL="0" indent="0" algn="l">
               <a:buNone/>
             </a:pPr>
             <a:r>
@@ -10088,7 +10479,7 @@
           <a:bodyPr wrap="square" rtlCol="0" anchor="ctr"/>
           <a:lstStyle/>
           <a:p>
-            <a:pPr algn="ctr" indent="0" marL="0">
+            <a:pPr marL="0" indent="0" algn="ctr">
               <a:buNone/>
             </a:pPr>
             <a:r>
@@ -10127,9 +10518,20 @@
           <a:bodyPr wrap="square" rtlCol="0" anchor="ctr"/>
           <a:lstStyle/>
           <a:p>
-            <a:pPr algn="ctr" indent="0" marL="0">
-              <a:buNone/>
-            </a:pPr>
+            <a:pPr marL="0" indent="0" algn="ctr">
+              <a:buNone/>
+            </a:pPr>
+            <a:r>
+              <a:rPr lang="en-US" sz="1300" dirty="0" err="1">
+                <a:solidFill>
+                  <a:srgbClr val="374151"/>
+                </a:solidFill>
+                <a:latin typeface="Calibri" pitchFamily="34" charset="0"/>
+                <a:ea typeface="Calibri" pitchFamily="34" charset="-122"/>
+                <a:cs typeface="Calibri" pitchFamily="34" charset="-120"/>
+              </a:rPr>
+              <a:t>hamma</a:t>
+            </a:r>
             <a:r>
               <a:rPr lang="en-US" sz="1300" dirty="0">
                 <a:solidFill>
@@ -10139,7 +10541,18 @@
                 <a:ea typeface="Calibri" pitchFamily="34" charset="-122"/>
                 <a:cs typeface="Calibri" pitchFamily="34" charset="-120"/>
               </a:rPr>
-              <a:t>bor</a:t>
+              <a:t> </a:t>
+            </a:r>
+            <a:r>
+              <a:rPr lang="en-US" sz="1300" dirty="0" err="1">
+                <a:solidFill>
+                  <a:srgbClr val="374151"/>
+                </a:solidFill>
+                <a:latin typeface="Calibri" pitchFamily="34" charset="0"/>
+                <a:ea typeface="Calibri" pitchFamily="34" charset="-122"/>
+                <a:cs typeface="Calibri" pitchFamily="34" charset="-120"/>
+              </a:rPr>
+              <a:t>viloyat</a:t>
             </a:r>
             <a:endParaRPr lang="en-US" sz="1300" dirty="0"/>
           </a:p>
@@ -10164,6 +10577,13 @@
           </a:solidFill>
           <a:ln/>
         </p:spPr>
+        <p:txBody>
+          <a:bodyPr/>
+          <a:lstStyle/>
+          <a:p>
+            <a:endParaRPr lang="ko-KR" altLang="en-US"/>
+          </a:p>
+        </p:txBody>
       </p:sp>
       <p:sp>
         <p:nvSpPr>
@@ -10186,7 +10606,7 @@
           <a:bodyPr wrap="square" rtlCol="0" anchor="ctr"/>
           <a:lstStyle/>
           <a:p>
-            <a:pPr algn="ctr" indent="0" marL="0">
+            <a:pPr marL="0" indent="0" algn="ctr">
               <a:buNone/>
             </a:pPr>
             <a:r>
@@ -10226,6 +10646,13 @@
             <a:prstDash val="solid"/>
           </a:ln>
         </p:spPr>
+        <p:txBody>
+          <a:bodyPr/>
+          <a:lstStyle/>
+          <a:p>
+            <a:endParaRPr lang="ko-KR" altLang="en-US"/>
+          </a:p>
+        </p:txBody>
       </p:sp>
       <p:sp>
         <p:nvSpPr>
@@ -10248,7 +10675,7 @@
           <a:bodyPr wrap="square" rtlCol="0" anchor="ctr"/>
           <a:lstStyle/>
           <a:p>
-            <a:pPr algn="l" indent="0" marL="0">
+            <a:pPr marL="0" indent="0" algn="l">
               <a:buNone/>
             </a:pPr>
             <a:r>
@@ -10287,7 +10714,7 @@
           <a:bodyPr wrap="square" rtlCol="0" anchor="ctr"/>
           <a:lstStyle/>
           <a:p>
-            <a:pPr algn="ctr" indent="0" marL="0">
+            <a:pPr marL="0" indent="0" algn="ctr">
               <a:buNone/>
             </a:pPr>
             <a:r>
@@ -10326,7 +10753,7 @@
           <a:bodyPr wrap="square" rtlCol="0" anchor="ctr"/>
           <a:lstStyle/>
           <a:p>
-            <a:pPr algn="ctr" indent="0" marL="0">
+            <a:pPr marL="0" indent="0" algn="ctr">
               <a:buNone/>
             </a:pPr>
             <a:r>
@@ -10363,6 +10790,13 @@
           </a:solidFill>
           <a:ln/>
         </p:spPr>
+        <p:txBody>
+          <a:bodyPr/>
+          <a:lstStyle/>
+          <a:p>
+            <a:endParaRPr lang="ko-KR" altLang="en-US"/>
+          </a:p>
+        </p:txBody>
       </p:sp>
       <p:sp>
         <p:nvSpPr>
@@ -10385,7 +10819,7 @@
           <a:bodyPr wrap="square" rtlCol="0" anchor="ctr"/>
           <a:lstStyle/>
           <a:p>
-            <a:pPr algn="ctr" indent="0" marL="0">
+            <a:pPr marL="0" indent="0" algn="ctr">
               <a:buNone/>
             </a:pPr>
             <a:r>
@@ -10425,6 +10859,13 @@
             <a:prstDash val="solid"/>
           </a:ln>
         </p:spPr>
+        <p:txBody>
+          <a:bodyPr/>
+          <a:lstStyle/>
+          <a:p>
+            <a:endParaRPr lang="ko-KR" altLang="en-US"/>
+          </a:p>
+        </p:txBody>
       </p:sp>
       <p:sp>
         <p:nvSpPr>
@@ -10447,7 +10888,7 @@
           <a:bodyPr wrap="square" rtlCol="0" anchor="ctr"/>
           <a:lstStyle/>
           <a:p>
-            <a:pPr algn="l" indent="0" marL="0">
+            <a:pPr marL="0" indent="0" algn="l">
               <a:buNone/>
             </a:pPr>
             <a:r>
@@ -10486,7 +10927,7 @@
           <a:bodyPr wrap="square" rtlCol="0" anchor="ctr"/>
           <a:lstStyle/>
           <a:p>
-            <a:pPr algn="ctr" indent="0" marL="0">
+            <a:pPr marL="0" indent="0" algn="ctr">
               <a:buNone/>
             </a:pPr>
             <a:r>
@@ -10525,7 +10966,7 @@
           <a:bodyPr wrap="square" rtlCol="0" anchor="ctr"/>
           <a:lstStyle/>
           <a:p>
-            <a:pPr algn="ctr" indent="0" marL="0">
+            <a:pPr marL="0" indent="0" algn="ctr">
               <a:buNone/>
             </a:pPr>
             <a:r>
@@ -10562,6 +11003,13 @@
           </a:solidFill>
           <a:ln/>
         </p:spPr>
+        <p:txBody>
+          <a:bodyPr/>
+          <a:lstStyle/>
+          <a:p>
+            <a:endParaRPr lang="ko-KR" altLang="en-US"/>
+          </a:p>
+        </p:txBody>
       </p:sp>
       <p:sp>
         <p:nvSpPr>
@@ -10584,7 +11032,7 @@
           <a:bodyPr wrap="square" rtlCol="0" anchor="ctr"/>
           <a:lstStyle/>
           <a:p>
-            <a:pPr algn="ctr" indent="0" marL="0">
+            <a:pPr marL="0" indent="0" algn="ctr">
               <a:buNone/>
             </a:pPr>
             <a:r>
@@ -10624,6 +11072,13 @@
             <a:prstDash val="solid"/>
           </a:ln>
         </p:spPr>
+        <p:txBody>
+          <a:bodyPr/>
+          <a:lstStyle/>
+          <a:p>
+            <a:endParaRPr lang="ko-KR" altLang="en-US"/>
+          </a:p>
+        </p:txBody>
       </p:sp>
       <p:sp>
         <p:nvSpPr>
@@ -10646,7 +11101,7 @@
           <a:bodyPr wrap="square" rtlCol="0" anchor="ctr"/>
           <a:lstStyle/>
           <a:p>
-            <a:pPr algn="l" indent="0" marL="0">
+            <a:pPr marL="0" indent="0" algn="l">
               <a:buNone/>
             </a:pPr>
             <a:r>
@@ -10685,7 +11140,7 @@
           <a:bodyPr wrap="square" rtlCol="0" anchor="ctr"/>
           <a:lstStyle/>
           <a:p>
-            <a:pPr algn="ctr" indent="0" marL="0">
+            <a:pPr marL="0" indent="0" algn="ctr">
               <a:buNone/>
             </a:pPr>
             <a:r>
@@ -10724,11 +11179,11 @@
           <a:bodyPr wrap="square" rtlCol="0" anchor="ctr"/>
           <a:lstStyle/>
           <a:p>
-            <a:pPr algn="ctr" indent="0" marL="0">
-              <a:buNone/>
-            </a:pPr>
-            <a:r>
-              <a:rPr lang="en-US" sz="1300" dirty="0">
+            <a:pPr marL="0" indent="0" algn="ctr">
+              <a:buNone/>
+            </a:pPr>
+            <a:r>
+              <a:rPr lang="en-US" sz="1300" dirty="0" err="1">
                 <a:solidFill>
                   <a:srgbClr val="374151"/>
                 </a:solidFill>
@@ -10736,7 +11191,7 @@
                 <a:ea typeface="Calibri" pitchFamily="34" charset="-122"/>
                 <a:cs typeface="Calibri" pitchFamily="34" charset="-120"/>
               </a:rPr>
-              <a:t>yo'q</a:t>
+              <a:t>bor</a:t>
             </a:r>
             <a:endParaRPr lang="en-US" sz="1300" dirty="0"/>
           </a:p>
@@ -10761,6 +11216,13 @@
           </a:solidFill>
           <a:ln/>
         </p:spPr>
+        <p:txBody>
+          <a:bodyPr/>
+          <a:lstStyle/>
+          <a:p>
+            <a:endParaRPr lang="ko-KR" altLang="en-US"/>
+          </a:p>
+        </p:txBody>
       </p:sp>
       <p:sp>
         <p:nvSpPr>
@@ -10783,7 +11245,7 @@
           <a:bodyPr wrap="square" rtlCol="0" anchor="ctr"/>
           <a:lstStyle/>
           <a:p>
-            <a:pPr algn="ctr" indent="0" marL="0">
+            <a:pPr marL="0" indent="0" algn="ctr">
               <a:buNone/>
             </a:pPr>
             <a:r>
@@ -10823,6 +11285,13 @@
             <a:prstDash val="solid"/>
           </a:ln>
         </p:spPr>
+        <p:txBody>
+          <a:bodyPr/>
+          <a:lstStyle/>
+          <a:p>
+            <a:endParaRPr lang="ko-KR" altLang="en-US"/>
+          </a:p>
+        </p:txBody>
       </p:sp>
       <p:sp>
         <p:nvSpPr>
@@ -10845,7 +11314,7 @@
           <a:bodyPr wrap="square" rtlCol="0" anchor="ctr"/>
           <a:lstStyle/>
           <a:p>
-            <a:pPr indent="0" marL="0">
+            <a:pPr marL="0" indent="0">
               <a:buNone/>
             </a:pPr>
             <a:r>
@@ -10884,7 +11353,7 @@
           <a:bodyPr wrap="square" rtlCol="0" anchor="ctr"/>
           <a:lstStyle/>
           <a:p>
-            <a:pPr algn="r" indent="0" marL="0">
+            <a:pPr marL="0" indent="0" algn="r">
               <a:buNone/>
             </a:pPr>
             <a:r>
@@ -10918,6 +11387,7 @@
         <a:solidFill>
           <a:srgbClr val="FFFFFF"/>
         </a:solidFill>
+        <a:effectLst/>
       </p:bgPr>
     </p:bg>
     <p:spTree>
@@ -10955,7 +11425,7 @@
           <a:bodyPr wrap="square" rtlCol="0" anchor="ctr"/>
           <a:lstStyle/>
           <a:p>
-            <a:pPr indent="0" marL="0">
+            <a:pPr marL="0" indent="0">
               <a:buNone/>
             </a:pPr>
             <a:r>
@@ -10994,7 +11464,7 @@
           <a:bodyPr wrap="square" rtlCol="0" anchor="ctr"/>
           <a:lstStyle/>
           <a:p>
-            <a:pPr indent="0" marL="0">
+            <a:pPr marL="0" indent="0">
               <a:buNone/>
             </a:pPr>
             <a:r>
@@ -11038,13 +11508,20 @@
             <a:prstDash val="solid"/>
           </a:ln>
           <a:effectLst>
-            <a:outerShdw sx="100000" sy="100000" kx="0" ky="0" algn="bl" rotWithShape="0" blurRad="101600" dist="25400" dir="5400000">
+            <a:outerShdw blurRad="101600" dist="25400" dir="5400000" algn="bl" rotWithShape="0">
               <a:srgbClr val="B7C3BC">
                 <a:alpha val="35000"/>
               </a:srgbClr>
             </a:outerShdw>
           </a:effectLst>
         </p:spPr>
+        <p:txBody>
+          <a:bodyPr/>
+          <a:lstStyle/>
+          <a:p>
+            <a:endParaRPr lang="ko-KR" altLang="en-US"/>
+          </a:p>
+        </p:txBody>
       </p:sp>
       <p:sp>
         <p:nvSpPr>
@@ -11065,6 +11542,13 @@
           </a:solidFill>
           <a:ln/>
         </p:spPr>
+        <p:txBody>
+          <a:bodyPr/>
+          <a:lstStyle/>
+          <a:p>
+            <a:endParaRPr lang="ko-KR" altLang="en-US"/>
+          </a:p>
+        </p:txBody>
       </p:sp>
       <p:sp>
         <p:nvSpPr>
@@ -11087,7 +11571,7 @@
           <a:bodyPr wrap="square" rtlCol="0" anchor="ctr"/>
           <a:lstStyle/>
           <a:p>
-            <a:pPr algn="ctr" indent="0" marL="0">
+            <a:pPr marL="0" indent="0" algn="ctr">
               <a:buNone/>
             </a:pPr>
             <a:r>
@@ -11126,7 +11610,7 @@
           <a:bodyPr wrap="square" rtlCol="0" anchor="ctr"/>
           <a:lstStyle/>
           <a:p>
-            <a:pPr indent="0" marL="0">
+            <a:pPr marL="0" indent="0">
               <a:buNone/>
             </a:pPr>
             <a:r>
@@ -11165,7 +11649,7 @@
           <a:bodyPr wrap="square" rtlCol="0" anchor="ctr"/>
           <a:lstStyle/>
           <a:p>
-            <a:pPr indent="0" marL="0">
+            <a:pPr marL="0" indent="0">
               <a:buNone/>
             </a:pPr>
             <a:r>
@@ -11209,13 +11693,20 @@
             <a:prstDash val="solid"/>
           </a:ln>
           <a:effectLst>
-            <a:outerShdw sx="100000" sy="100000" kx="0" ky="0" algn="bl" rotWithShape="0" blurRad="101600" dist="25400" dir="5400000">
+            <a:outerShdw blurRad="101600" dist="25400" dir="5400000" algn="bl" rotWithShape="0">
               <a:srgbClr val="B7C3BC">
                 <a:alpha val="35000"/>
               </a:srgbClr>
             </a:outerShdw>
           </a:effectLst>
         </p:spPr>
+        <p:txBody>
+          <a:bodyPr/>
+          <a:lstStyle/>
+          <a:p>
+            <a:endParaRPr lang="ko-KR" altLang="en-US"/>
+          </a:p>
+        </p:txBody>
       </p:sp>
       <p:sp>
         <p:nvSpPr>
@@ -11236,6 +11727,13 @@
           </a:solidFill>
           <a:ln/>
         </p:spPr>
+        <p:txBody>
+          <a:bodyPr/>
+          <a:lstStyle/>
+          <a:p>
+            <a:endParaRPr lang="ko-KR" altLang="en-US"/>
+          </a:p>
+        </p:txBody>
       </p:sp>
       <p:sp>
         <p:nvSpPr>
@@ -11258,7 +11756,7 @@
           <a:bodyPr wrap="square" rtlCol="0" anchor="ctr"/>
           <a:lstStyle/>
           <a:p>
-            <a:pPr algn="ctr" indent="0" marL="0">
+            <a:pPr marL="0" indent="0" algn="ctr">
               <a:buNone/>
             </a:pPr>
             <a:r>
@@ -11297,7 +11795,7 @@
           <a:bodyPr wrap="square" rtlCol="0" anchor="ctr"/>
           <a:lstStyle/>
           <a:p>
-            <a:pPr indent="0" marL="0">
+            <a:pPr marL="0" indent="0">
               <a:buNone/>
             </a:pPr>
             <a:r>
@@ -11336,7 +11834,7 @@
           <a:bodyPr wrap="square" rtlCol="0" anchor="ctr"/>
           <a:lstStyle/>
           <a:p>
-            <a:pPr indent="0" marL="0">
+            <a:pPr marL="0" indent="0">
               <a:buNone/>
             </a:pPr>
             <a:r>
@@ -11380,13 +11878,20 @@
             <a:prstDash val="solid"/>
           </a:ln>
           <a:effectLst>
-            <a:outerShdw sx="100000" sy="100000" kx="0" ky="0" algn="bl" rotWithShape="0" blurRad="101600" dist="25400" dir="5400000">
+            <a:outerShdw blurRad="101600" dist="25400" dir="5400000" algn="bl" rotWithShape="0">
               <a:srgbClr val="B7C3BC">
                 <a:alpha val="35000"/>
               </a:srgbClr>
             </a:outerShdw>
           </a:effectLst>
         </p:spPr>
+        <p:txBody>
+          <a:bodyPr/>
+          <a:lstStyle/>
+          <a:p>
+            <a:endParaRPr lang="ko-KR" altLang="en-US"/>
+          </a:p>
+        </p:txBody>
       </p:sp>
       <p:sp>
         <p:nvSpPr>
@@ -11407,6 +11912,13 @@
           </a:solidFill>
           <a:ln/>
         </p:spPr>
+        <p:txBody>
+          <a:bodyPr/>
+          <a:lstStyle/>
+          <a:p>
+            <a:endParaRPr lang="ko-KR" altLang="en-US"/>
+          </a:p>
+        </p:txBody>
       </p:sp>
       <p:sp>
         <p:nvSpPr>
@@ -11429,7 +11941,7 @@
           <a:bodyPr wrap="square" rtlCol="0" anchor="ctr"/>
           <a:lstStyle/>
           <a:p>
-            <a:pPr algn="ctr" indent="0" marL="0">
+            <a:pPr marL="0" indent="0" algn="ctr">
               <a:buNone/>
             </a:pPr>
             <a:r>
@@ -11468,7 +11980,7 @@
           <a:bodyPr wrap="square" rtlCol="0" anchor="ctr"/>
           <a:lstStyle/>
           <a:p>
-            <a:pPr indent="0" marL="0">
+            <a:pPr marL="0" indent="0">
               <a:buNone/>
             </a:pPr>
             <a:r>
@@ -11507,7 +12019,7 @@
           <a:bodyPr wrap="square" rtlCol="0" anchor="ctr"/>
           <a:lstStyle/>
           <a:p>
-            <a:pPr indent="0" marL="0">
+            <a:pPr marL="0" indent="0">
               <a:buNone/>
             </a:pPr>
             <a:r>
@@ -11551,13 +12063,20 @@
             <a:prstDash val="solid"/>
           </a:ln>
           <a:effectLst>
-            <a:outerShdw sx="100000" sy="100000" kx="0" ky="0" algn="bl" rotWithShape="0" blurRad="101600" dist="25400" dir="5400000">
+            <a:outerShdw blurRad="101600" dist="25400" dir="5400000" algn="bl" rotWithShape="0">
               <a:srgbClr val="B7C3BC">
                 <a:alpha val="35000"/>
               </a:srgbClr>
             </a:outerShdw>
           </a:effectLst>
         </p:spPr>
+        <p:txBody>
+          <a:bodyPr/>
+          <a:lstStyle/>
+          <a:p>
+            <a:endParaRPr lang="ko-KR" altLang="en-US"/>
+          </a:p>
+        </p:txBody>
       </p:sp>
       <p:sp>
         <p:nvSpPr>
@@ -11578,6 +12097,13 @@
           </a:solidFill>
           <a:ln/>
         </p:spPr>
+        <p:txBody>
+          <a:bodyPr/>
+          <a:lstStyle/>
+          <a:p>
+            <a:endParaRPr lang="ko-KR" altLang="en-US"/>
+          </a:p>
+        </p:txBody>
       </p:sp>
       <p:sp>
         <p:nvSpPr>
@@ -11600,7 +12126,7 @@
           <a:bodyPr wrap="square" rtlCol="0" anchor="ctr"/>
           <a:lstStyle/>
           <a:p>
-            <a:pPr algn="ctr" indent="0" marL="0">
+            <a:pPr marL="0" indent="0" algn="ctr">
               <a:buNone/>
             </a:pPr>
             <a:r>
@@ -11639,7 +12165,7 @@
           <a:bodyPr wrap="square" rtlCol="0" anchor="ctr"/>
           <a:lstStyle/>
           <a:p>
-            <a:pPr indent="0" marL="0">
+            <a:pPr marL="0" indent="0">
               <a:buNone/>
             </a:pPr>
             <a:r>
@@ -11678,7 +12204,7 @@
           <a:bodyPr wrap="square" rtlCol="0" anchor="ctr"/>
           <a:lstStyle/>
           <a:p>
-            <a:pPr indent="0" marL="0">
+            <a:pPr marL="0" indent="0">
               <a:buNone/>
             </a:pPr>
             <a:r>
@@ -11717,7 +12243,7 @@
           <a:bodyPr wrap="square" rtlCol="0" anchor="ctr"/>
           <a:lstStyle/>
           <a:p>
-            <a:pPr indent="0" marL="0">
+            <a:pPr marL="0" indent="0">
               <a:buNone/>
             </a:pPr>
             <a:r>
@@ -11756,7 +12282,7 @@
           <a:bodyPr wrap="square" rtlCol="0" anchor="ctr"/>
           <a:lstStyle/>
           <a:p>
-            <a:pPr algn="r" indent="0" marL="0">
+            <a:pPr marL="0" indent="0" algn="r">
               <a:buNone/>
             </a:pPr>
             <a:r>
@@ -12075,4 +12601,319 @@
     </a:ext>
   </a:extLst>
 </a:theme>
+</file>
+
+<file path=ppt/theme/theme2.xml><?xml version="1.0" encoding="utf-8"?>
+<a:theme xmlns:a="http://schemas.openxmlformats.org/drawingml/2006/main" name="Office Theme">
+  <a:themeElements>
+    <a:clrScheme name="Office">
+      <a:dk1>
+        <a:sysClr val="windowText" lastClr="000000"/>
+      </a:dk1>
+      <a:lt1>
+        <a:sysClr val="window" lastClr="FFFFFF"/>
+      </a:lt1>
+      <a:dk2>
+        <a:srgbClr val="0E2841"/>
+      </a:dk2>
+      <a:lt2>
+        <a:srgbClr val="E8E8E8"/>
+      </a:lt2>
+      <a:accent1>
+        <a:srgbClr val="156082"/>
+      </a:accent1>
+      <a:accent2>
+        <a:srgbClr val="E97132"/>
+      </a:accent2>
+      <a:accent3>
+        <a:srgbClr val="196B24"/>
+      </a:accent3>
+      <a:accent4>
+        <a:srgbClr val="0F9ED5"/>
+      </a:accent4>
+      <a:accent5>
+        <a:srgbClr val="A02B93"/>
+      </a:accent5>
+      <a:accent6>
+        <a:srgbClr val="4EA72E"/>
+      </a:accent6>
+      <a:hlink>
+        <a:srgbClr val="467886"/>
+      </a:hlink>
+      <a:folHlink>
+        <a:srgbClr val="96607D"/>
+      </a:folHlink>
+    </a:clrScheme>
+    <a:fontScheme name="Office">
+      <a:majorFont>
+        <a:latin typeface="맑은 고딕" panose="02110004020202020204"/>
+        <a:ea typeface=""/>
+        <a:cs typeface=""/>
+        <a:font script="Jpan" typeface="游ゴシック Light"/>
+        <a:font script="Hang" typeface="맑은 고딕"/>
+        <a:font script="Hans" typeface="等线 Light"/>
+        <a:font script="Hant" typeface="新細明體"/>
+        <a:font script="Arab" typeface="Times New Roman"/>
+        <a:font script="Hebr" typeface="Times New Roman"/>
+        <a:font script="Thai" typeface="Angsana New"/>
+        <a:font script="Ethi" typeface="Nyala"/>
+        <a:font script="Beng" typeface="Vrinda"/>
+        <a:font script="Gujr" typeface="Shruti"/>
+        <a:font script="Khmr" typeface="MoolBoran"/>
+        <a:font script="Knda" typeface="Tunga"/>
+        <a:font script="Guru" typeface="Raavi"/>
+        <a:font script="Cans" typeface="Euphemia"/>
+        <a:font script="Cher" typeface="Plantagenet Cherokee"/>
+        <a:font script="Yiii" typeface="Microsoft Yi Baiti"/>
+        <a:font script="Tibt" typeface="Microsoft Himalaya"/>
+        <a:font script="Thaa" typeface="MV Boli"/>
+        <a:font script="Deva" typeface="Mangal"/>
+        <a:font script="Telu" typeface="Gautami"/>
+        <a:font script="Taml" typeface="Latha"/>
+        <a:font script="Syrc" typeface="Estrangelo Edessa"/>
+        <a:font script="Orya" typeface="Kalinga"/>
+        <a:font script="Mlym" typeface="Kartika"/>
+        <a:font script="Laoo" typeface="DokChampa"/>
+        <a:font script="Sinh" typeface="Iskoola Pota"/>
+        <a:font script="Mong" typeface="Mongolian Baiti"/>
+        <a:font script="Viet" typeface="Times New Roman"/>
+        <a:font script="Uigh" typeface="Microsoft Uighur"/>
+        <a:font script="Geor" typeface="Sylfaen"/>
+        <a:font script="Armn" typeface="Arial"/>
+        <a:font script="Bugi" typeface="Leelawadee UI"/>
+        <a:font script="Bopo" typeface="Microsoft JhengHei"/>
+        <a:font script="Java" typeface="Javanese Text"/>
+        <a:font script="Lisu" typeface="Segoe UI"/>
+        <a:font script="Mymr" typeface="Myanmar Text"/>
+        <a:font script="Nkoo" typeface="Ebrima"/>
+        <a:font script="Olck" typeface="Nirmala UI"/>
+        <a:font script="Osma" typeface="Ebrima"/>
+        <a:font script="Phag" typeface="Phagspa"/>
+        <a:font script="Syrn" typeface="Estrangelo Edessa"/>
+        <a:font script="Syrj" typeface="Estrangelo Edessa"/>
+        <a:font script="Syre" typeface="Estrangelo Edessa"/>
+        <a:font script="Sora" typeface="Nirmala UI"/>
+        <a:font script="Tale" typeface="Microsoft Tai Le"/>
+        <a:font script="Talu" typeface="Microsoft New Tai Lue"/>
+        <a:font script="Tfng" typeface="Ebrima"/>
+      </a:majorFont>
+      <a:minorFont>
+        <a:latin typeface="맑은 고딕" panose="02110004020202020204"/>
+        <a:ea typeface=""/>
+        <a:cs typeface=""/>
+        <a:font script="Jpan" typeface="游ゴシック"/>
+        <a:font script="Hang" typeface="맑은 고딕"/>
+        <a:font script="Hans" typeface="等线"/>
+        <a:font script="Hant" typeface="新細明體"/>
+        <a:font script="Arab" typeface="Arial"/>
+        <a:font script="Hebr" typeface="Arial"/>
+        <a:font script="Thai" typeface="Cordia New"/>
+        <a:font script="Ethi" typeface="Nyala"/>
+        <a:font script="Beng" typeface="Vrinda"/>
+        <a:font script="Gujr" typeface="Shruti"/>
+        <a:font script="Khmr" typeface="DaunPenh"/>
+        <a:font script="Knda" typeface="Tunga"/>
+        <a:font script="Guru" typeface="Raavi"/>
+        <a:font script="Cans" typeface="Euphemia"/>
+        <a:font script="Cher" typeface="Plantagenet Cherokee"/>
+        <a:font script="Yiii" typeface="Microsoft Yi Baiti"/>
+        <a:font script="Tibt" typeface="Microsoft Himalaya"/>
+        <a:font script="Thaa" typeface="MV Boli"/>
+        <a:font script="Deva" typeface="Mangal"/>
+        <a:font script="Telu" typeface="Gautami"/>
+        <a:font script="Taml" typeface="Latha"/>
+        <a:font script="Syrc" typeface="Estrangelo Edessa"/>
+        <a:font script="Orya" typeface="Kalinga"/>
+        <a:font script="Mlym" typeface="Kartika"/>
+        <a:font script="Laoo" typeface="DokChampa"/>
+        <a:font script="Sinh" typeface="Iskoola Pota"/>
+        <a:font script="Mong" typeface="Mongolian Baiti"/>
+        <a:font script="Viet" typeface="Arial"/>
+        <a:font script="Uigh" typeface="Microsoft Uighur"/>
+        <a:font script="Geor" typeface="Sylfaen"/>
+        <a:font script="Armn" typeface="Arial"/>
+        <a:font script="Bugi" typeface="Leelawadee UI"/>
+        <a:font script="Bopo" typeface="Microsoft JhengHei"/>
+        <a:font script="Java" typeface="Javanese Text"/>
+        <a:font script="Lisu" typeface="Segoe UI"/>
+        <a:font script="Mymr" typeface="Myanmar Text"/>
+        <a:font script="Nkoo" typeface="Ebrima"/>
+        <a:font script="Olck" typeface="Nirmala UI"/>
+        <a:font script="Osma" typeface="Ebrima"/>
+        <a:font script="Phag" typeface="Phagspa"/>
+        <a:font script="Syrn" typeface="Estrangelo Edessa"/>
+        <a:font script="Syrj" typeface="Estrangelo Edessa"/>
+        <a:font script="Syre" typeface="Estrangelo Edessa"/>
+        <a:font script="Sora" typeface="Nirmala UI"/>
+        <a:font script="Tale" typeface="Microsoft Tai Le"/>
+        <a:font script="Talu" typeface="Microsoft New Tai Lue"/>
+        <a:font script="Tfng" typeface="Ebrima"/>
+      </a:minorFont>
+    </a:fontScheme>
+    <a:fmtScheme name="Office">
+      <a:fillStyleLst>
+        <a:solidFill>
+          <a:schemeClr val="phClr"/>
+        </a:solidFill>
+        <a:gradFill rotWithShape="1">
+          <a:gsLst>
+            <a:gs pos="0">
+              <a:schemeClr val="phClr">
+                <a:lumMod val="110000"/>
+                <a:satMod val="105000"/>
+                <a:tint val="67000"/>
+              </a:schemeClr>
+            </a:gs>
+            <a:gs pos="50000">
+              <a:schemeClr val="phClr">
+                <a:lumMod val="105000"/>
+                <a:satMod val="103000"/>
+                <a:tint val="73000"/>
+              </a:schemeClr>
+            </a:gs>
+            <a:gs pos="100000">
+              <a:schemeClr val="phClr">
+                <a:lumMod val="105000"/>
+                <a:satMod val="109000"/>
+                <a:tint val="81000"/>
+              </a:schemeClr>
+            </a:gs>
+          </a:gsLst>
+          <a:lin ang="5400000" scaled="0"/>
+        </a:gradFill>
+        <a:gradFill rotWithShape="1">
+          <a:gsLst>
+            <a:gs pos="0">
+              <a:schemeClr val="phClr">
+                <a:satMod val="103000"/>
+                <a:lumMod val="102000"/>
+                <a:tint val="94000"/>
+              </a:schemeClr>
+            </a:gs>
+            <a:gs pos="50000">
+              <a:schemeClr val="phClr">
+                <a:satMod val="110000"/>
+                <a:lumMod val="100000"/>
+                <a:shade val="100000"/>
+              </a:schemeClr>
+            </a:gs>
+            <a:gs pos="100000">
+              <a:schemeClr val="phClr">
+                <a:lumMod val="99000"/>
+                <a:satMod val="120000"/>
+                <a:shade val="78000"/>
+              </a:schemeClr>
+            </a:gs>
+          </a:gsLst>
+          <a:lin ang="5400000" scaled="0"/>
+        </a:gradFill>
+      </a:fillStyleLst>
+      <a:lnStyleLst>
+        <a:ln w="12700" cap="flat" cmpd="sng" algn="ctr">
+          <a:solidFill>
+            <a:schemeClr val="phClr"/>
+          </a:solidFill>
+          <a:prstDash val="solid"/>
+          <a:miter lim="800000"/>
+        </a:ln>
+        <a:ln w="19050" cap="flat" cmpd="sng" algn="ctr">
+          <a:solidFill>
+            <a:schemeClr val="phClr"/>
+          </a:solidFill>
+          <a:prstDash val="solid"/>
+          <a:miter lim="800000"/>
+        </a:ln>
+        <a:ln w="25400" cap="flat" cmpd="sng" algn="ctr">
+          <a:solidFill>
+            <a:schemeClr val="phClr"/>
+          </a:solidFill>
+          <a:prstDash val="solid"/>
+          <a:miter lim="800000"/>
+        </a:ln>
+      </a:lnStyleLst>
+      <a:effectStyleLst>
+        <a:effectStyle>
+          <a:effectLst/>
+        </a:effectStyle>
+        <a:effectStyle>
+          <a:effectLst/>
+        </a:effectStyle>
+        <a:effectStyle>
+          <a:effectLst>
+            <a:outerShdw blurRad="57150" dist="19050" dir="5400000" algn="ctr" rotWithShape="0">
+              <a:srgbClr val="000000">
+                <a:alpha val="63000"/>
+              </a:srgbClr>
+            </a:outerShdw>
+          </a:effectLst>
+        </a:effectStyle>
+      </a:effectStyleLst>
+      <a:bgFillStyleLst>
+        <a:solidFill>
+          <a:schemeClr val="phClr"/>
+        </a:solidFill>
+        <a:solidFill>
+          <a:schemeClr val="phClr">
+            <a:tint val="95000"/>
+            <a:satMod val="170000"/>
+          </a:schemeClr>
+        </a:solidFill>
+        <a:gradFill rotWithShape="1">
+          <a:gsLst>
+            <a:gs pos="0">
+              <a:schemeClr val="phClr">
+                <a:tint val="93000"/>
+                <a:satMod val="150000"/>
+                <a:shade val="98000"/>
+                <a:lumMod val="102000"/>
+              </a:schemeClr>
+            </a:gs>
+            <a:gs pos="50000">
+              <a:schemeClr val="phClr">
+                <a:tint val="98000"/>
+                <a:satMod val="130000"/>
+                <a:shade val="90000"/>
+                <a:lumMod val="103000"/>
+              </a:schemeClr>
+            </a:gs>
+            <a:gs pos="100000">
+              <a:schemeClr val="phClr">
+                <a:shade val="63000"/>
+                <a:satMod val="120000"/>
+              </a:schemeClr>
+            </a:gs>
+          </a:gsLst>
+          <a:lin ang="5400000" scaled="0"/>
+        </a:gradFill>
+      </a:bgFillStyleLst>
+    </a:fmtScheme>
+  </a:themeElements>
+  <a:objectDefaults>
+    <a:lnDef>
+      <a:spPr/>
+      <a:bodyPr/>
+      <a:lstStyle/>
+      <a:style>
+        <a:lnRef idx="2">
+          <a:schemeClr val="accent1"/>
+        </a:lnRef>
+        <a:fillRef idx="0">
+          <a:schemeClr val="accent1"/>
+        </a:fillRef>
+        <a:effectRef idx="1">
+          <a:schemeClr val="accent1"/>
+        </a:effectRef>
+        <a:fontRef idx="minor">
+          <a:schemeClr val="tx1"/>
+        </a:fontRef>
+      </a:style>
+    </a:lnDef>
+  </a:objectDefaults>
+  <a:extraClrSchemeLst/>
+  <a:extLst>
+    <a:ext uri="{05A4C25C-085E-4340-85A3-A5531E510DB2}">
+      <thm15:themeFamily xmlns:thm15="http://schemas.microsoft.com/office/thememl/2012/main" name="Office Theme" id="{2E142A2C-CD16-42D6-873A-C26D2A0506FA}" vid="{1BDDFF52-6CD6-40A5-AB3C-68EB2F1E4D0A}"/>
+    </a:ext>
+  </a:extLst>
+</a:theme>
 </file>
</xml_diff>